<commit_message>
Strengthen proof-carrying change narrative
</commit_message>
<xml_diff>
--- a/submission/ChronosFix_复赛方案.pptx
+++ b/submission/ChronosFix_复赛方案.pptx
@@ -2714,7 +2714,7 @@
                 <a:ea typeface="Microsoft YaHei" pitchFamily="34" charset="-122"/>
                 <a:cs typeface="Microsoft YaHei" pitchFamily="34" charset="-120"/>
               </a:rPr>
-              <a:t>软件故障时间机器：把线上事故变成可复用研发质量资产</a:t>
+              <a:t>带证明的软件变更基础设施：把事故转成可审批 PR 与质量资产</a:t>
             </a:r>
             <a:endParaRPr lang="en-US" sz="1800" dirty="0"/>
           </a:p>
@@ -3344,7 +3344,7 @@
                 <a:ea typeface="Microsoft YaHei" pitchFamily="34" charset="-122"/>
                 <a:cs typeface="Microsoft YaHei" pitchFamily="34" charset="-120"/>
               </a:rPr>
-              <a:t>09 · 创新点三：RiskGate 与证据护照</a:t>
+              <a:t>09 · 创新点三：RiskGate 与 PR 证据护照</a:t>
             </a:r>
             <a:endParaRPr lang="en-US" sz="1050" dirty="0"/>
           </a:p>
@@ -3896,7 +3896,7 @@
                 <a:ea typeface="Microsoft YaHei" pitchFamily="34" charset="-122"/>
                 <a:cs typeface="Microsoft YaHei" pitchFamily="34" charset="-120"/>
               </a:rPr>
-              <a:t>证据护照</a:t>
+              <a:t>PR 证据护照</a:t>
             </a:r>
             <a:endParaRPr lang="en-US" sz="1500" dirty="0"/>
           </a:p>
@@ -3937,7 +3937,7 @@
                 <a:ea typeface="Microsoft YaHei" pitchFamily="34" charset="-122"/>
                 <a:cs typeface="Microsoft YaHei" pitchFamily="34" charset="-120"/>
               </a:rPr>
-              <a:t>• 根因证据</a:t>
+              <a:t>• GitHub PR 草案</a:t>
             </a:r>
             <a:endParaRPr lang="en-US" sz="1150" dirty="0"/>
           </a:p>
@@ -3954,7 +3954,7 @@
                 <a:ea typeface="Microsoft YaHei" pitchFamily="34" charset="-122"/>
                 <a:cs typeface="Microsoft YaHei" pitchFamily="34" charset="-120"/>
               </a:rPr>
-              <a:t>• 验证矩阵</a:t>
+              <a:t>• checks / diff</a:t>
             </a:r>
             <a:endParaRPr lang="en-US" sz="1150" dirty="0"/>
           </a:p>
@@ -9842,7 +9842,7 @@
                 <a:ea typeface="Microsoft YaHei" pitchFamily="34" charset="-122"/>
                 <a:cs typeface="Microsoft YaHei" pitchFamily="34" charset="-120"/>
               </a:rPr>
-              <a:t>把事故成本变成可交易、可复用、可审计的质量资产</a:t>
+              <a:t>把事故成本变成带证明的软件变更资产</a:t>
             </a:r>
             <a:endParaRPr lang="en-US" sz="2600" dirty="0"/>
           </a:p>
@@ -9883,7 +9883,7 @@
                 <a:ea typeface="Microsoft YaHei" pitchFamily="34" charset="-122"/>
                 <a:cs typeface="Microsoft YaHei" pitchFamily="34" charset="-120"/>
               </a:rPr>
-              <a:t>A-CFX 的护城河来自持续积累的反事实实验和质量资产库。</a:t>
+              <a:t>A-CFX 的护城河来自持续积累的反事实实验、PR 证据护照和质量资产库。</a:t>
             </a:r>
             <a:endParaRPr lang="en-US" sz="1300" dirty="0"/>
           </a:p>
@@ -10285,7 +10285,7 @@
                 <a:ea typeface="Microsoft YaHei" pitchFamily="34" charset="-122"/>
                 <a:cs typeface="Microsoft YaHei" pitchFamily="34" charset="-120"/>
               </a:rPr>
-              <a:t>故障基因包、证据护照模板和 Skill Candidate 可以开源共建或商业分发。</a:t>
+              <a:t>故障基因包、PR 证据护照模板和 Skill Candidate 可以开源共建或商业分发。</a:t>
             </a:r>
             <a:endParaRPr lang="en-US" sz="1150" dirty="0"/>
           </a:p>
@@ -10326,7 +10326,7 @@
                 <a:ea typeface="Microsoft YaHei" pitchFamily="34" charset="-122"/>
                 <a:cs typeface="Microsoft YaHei" pitchFamily="34" charset="-120"/>
               </a:rPr>
-              <a:t>收费形态：团队版 SaaS、企业私有化、云市场插件、Skill 市场、审计合规模块。</a:t>
+              <a:t>收费形态：团队版 SaaS、企业私有化、云市场插件、PR 证据包、Skill 市场、审计合规模块。</a:t>
             </a:r>
             <a:endParaRPr lang="en-US" sz="1650" dirty="0"/>
           </a:p>
@@ -11427,7 +11427,7 @@
                 <a:ea typeface="Microsoft YaHei" pitchFamily="34" charset="-122"/>
                 <a:cs typeface="Microsoft YaHei" pitchFamily="34" charset="-120"/>
               </a:rPr>
-              <a:t>让软件修复从经验猜测，升级为可证明、可审批、可回放、可复用的工程闭环。</a:t>
+              <a:t>让软件修复从经验猜测，升级为可证明、可审批、可回放、可复用的软件变更基础设施。</a:t>
             </a:r>
             <a:endParaRPr lang="en-US" sz="2000" dirty="0"/>
           </a:p>
@@ -12020,7 +12020,7 @@
                 <a:ea typeface="Microsoft YaHei" pitchFamily="34" charset="-122"/>
                 <a:cs typeface="Microsoft YaHei" pitchFamily="34" charset="-120"/>
               </a:rPr>
-              <a:t>01 · 复赛核心结论</a:t>
+              <a:t>01 · 底层逻辑</a:t>
             </a:r>
             <a:endParaRPr lang="en-US" sz="1050" dirty="0"/>
           </a:p>
@@ -12094,7 +12094,7 @@
               <a:buNone/>
             </a:pPr>
             <a:r>
-              <a:rPr lang="en-US" sz="2600" b="1" dirty="0">
+              <a:rPr lang="en-US" sz="2450" b="1" dirty="0">
                 <a:solidFill>
                   <a:srgbClr val="FFFFFF"/>
                 </a:solidFill>
@@ -12102,9 +12102,9 @@
                 <a:ea typeface="Microsoft YaHei" pitchFamily="34" charset="-122"/>
                 <a:cs typeface="Microsoft YaHei" pitchFamily="34" charset="-120"/>
               </a:rPr>
-              <a:t>A-CFX 已从创意方案升级为可验证工程</a:t>
-            </a:r>
-            <a:endParaRPr lang="en-US" sz="2600" dirty="0"/>
+              <a:t>A-CFX 不是自动修 Bug，而是带证明的软件变更基础设施</a:t>
+            </a:r>
+            <a:endParaRPr lang="en-US" sz="2450" dirty="0"/>
           </a:p>
         </p:txBody>
       </p:sp>
@@ -12236,7 +12236,7 @@
                 <a:ea typeface="Microsoft YaHei" pitchFamily="34" charset="-122"/>
                 <a:cs typeface="Microsoft YaHei" pitchFamily="34" charset="-120"/>
               </a:rPr>
-              <a:t>可运行</a:t>
+              <a:t>可证明</a:t>
             </a:r>
             <a:endParaRPr lang="en-US" sz="1500" dirty="0"/>
           </a:p>
@@ -12277,7 +12277,7 @@
                 <a:ea typeface="Microsoft YaHei" pitchFamily="34" charset="-122"/>
                 <a:cs typeface="Microsoft YaHei" pitchFamily="34" charset="-120"/>
               </a:rPr>
-              <a:t>Python 标准库即可运行核心 Demo；AgentTeams 风格入口会输出完整运行转录。</a:t>
+              <a:t>用反事实实验把“时间相关”变成“因果成立”，让根因结论可回放。</a:t>
             </a:r>
             <a:endParaRPr lang="en-US" sz="1150" dirty="0"/>
           </a:p>
@@ -12370,7 +12370,7 @@
                 <a:ea typeface="Microsoft YaHei" pitchFamily="34" charset="-122"/>
                 <a:cs typeface="Microsoft YaHei" pitchFamily="34" charset="-120"/>
               </a:rPr>
-              <a:t>可验证</a:t>
+              <a:t>可审批</a:t>
             </a:r>
             <a:endParaRPr lang="en-US" sz="1500" dirty="0"/>
           </a:p>
@@ -12411,7 +12411,7 @@
                 <a:ea typeface="Microsoft YaHei" pitchFamily="34" charset="-122"/>
                 <a:cs typeface="Microsoft YaHei" pitchFamily="34" charset="-120"/>
               </a:rPr>
-              <a:t>自动化测试、Trace、结构化日志、Metrics、评测报告和 proof-bundle 形成证据链。</a:t>
+              <a:t>补丁进入 GitHub PR 草案前携带 checks、RiskGate 状态、证据护照和回滚声明。</a:t>
             </a:r>
             <a:endParaRPr lang="en-US" sz="1150" dirty="0"/>
           </a:p>
@@ -12504,7 +12504,7 @@
                 <a:ea typeface="Microsoft YaHei" pitchFamily="34" charset="-122"/>
                 <a:cs typeface="Microsoft YaHei" pitchFamily="34" charset="-120"/>
               </a:rPr>
-              <a:t>可审计</a:t>
+              <a:t>可沉淀</a:t>
             </a:r>
             <a:endParaRPr lang="en-US" sz="1500" dirty="0"/>
           </a:p>
@@ -12545,7 +12545,7 @@
                 <a:ea typeface="Microsoft YaHei" pitchFamily="34" charset="-122"/>
                 <a:cs typeface="Microsoft YaHei" pitchFamily="34" charset="-120"/>
               </a:rPr>
-              <a:t>RiskGate 阻断未审批风险动作；Evidence Passport 记录因果、验证、风险、回滚和缺口。</a:t>
+              <a:t>事故结束后沉淀为故障基因包、证据模板和可评测 Skill，形成质量资产飞轮。</a:t>
             </a:r>
             <a:endParaRPr lang="en-US" sz="1150" dirty="0"/>
           </a:p>
@@ -12559,8 +12559,8 @@
         </p:nvSpPr>
         <p:spPr>
           <a:xfrm>
-            <a:off x="960120" y="4517136"/>
-            <a:ext cx="10149840" cy="384048"/>
+            <a:off x="868680" y="4407408"/>
+            <a:ext cx="10424160" cy="621792"/>
           </a:xfrm>
           <a:prstGeom prst="rect">
             <a:avLst/>
@@ -12578,7 +12578,7 @@
               <a:buNone/>
             </a:pPr>
             <a:r>
-              <a:rPr lang="en-US" sz="1700" b="1" dirty="0">
+              <a:rPr lang="en-US" sz="1550" b="1" dirty="0">
                 <a:solidFill>
                   <a:srgbClr val="FFFFFF"/>
                 </a:solidFill>
@@ -12586,9 +12586,26 @@
                 <a:ea typeface="Microsoft YaHei" pitchFamily="34" charset="-122"/>
                 <a:cs typeface="Microsoft YaHei" pitchFamily="34" charset="-120"/>
               </a:rPr>
-              <a:t>复赛版不把工具名当卖点，而是把接口契约、权限边界、失败处理和迁移成本讲清楚。</a:t>
-            </a:r>
-            <a:endParaRPr lang="en-US" sz="1700" dirty="0"/>
+              <a:t>事故证据 → 反事实证明根因 → 缺陷基因验证补丁 → RiskGate 审批</a:t>
+            </a:r>
+            <a:endParaRPr lang="en-US" sz="1550" dirty="0"/>
+          </a:p>
+          <a:p>
+            <a:pPr algn="ctr" indent="0" marL="0">
+              <a:buNone/>
+            </a:pPr>
+            <a:r>
+              <a:rPr lang="en-US" sz="1550" b="1" dirty="0">
+                <a:solidFill>
+                  <a:srgbClr val="FFFFFF"/>
+                </a:solidFill>
+                <a:latin typeface="Microsoft YaHei" pitchFamily="34" charset="0"/>
+                <a:ea typeface="Microsoft YaHei" pitchFamily="34" charset="-122"/>
+                <a:cs typeface="Microsoft YaHei" pitchFamily="34" charset="-120"/>
+              </a:rPr>
+              <a:t>GitHub PR / 证据护照 → Skill / 故障资产沉淀</a:t>
+            </a:r>
+            <a:endParaRPr lang="en-US" sz="1550" dirty="0"/>
           </a:p>
         </p:txBody>
       </p:sp>
@@ -12859,7 +12876,7 @@
                 <a:ea typeface="Microsoft YaHei" pitchFamily="34" charset="-122"/>
                 <a:cs typeface="Microsoft YaHei" pitchFamily="34" charset="-120"/>
               </a:rPr>
-              <a:t>一个订单故障，被转化为三类研发质量资产</a:t>
+              <a:t>一个订单故障，被转化为带证明的软件变更链</a:t>
             </a:r>
             <a:endParaRPr lang="en-US" sz="2600" dirty="0"/>
           </a:p>
@@ -12900,7 +12917,7 @@
                 <a:ea typeface="Microsoft YaHei" pitchFamily="34" charset="-122"/>
                 <a:cs typeface="Microsoft YaHei" pitchFamily="34" charset="-120"/>
               </a:rPr>
-              <a:t>目标不是自动猜测，而是先证明根因，再交付带证据的补丁。</a:t>
+              <a:t>目标不是自动猜测，而是先证明根因，再交付可审查、可回滚、可复用的 PR。</a:t>
             </a:r>
             <a:endParaRPr lang="en-US" sz="1300" dirty="0"/>
           </a:p>
@@ -12914,8 +12931,8 @@
         </p:nvSpPr>
         <p:spPr>
           <a:xfrm>
-            <a:off x="713232" y="2212848"/>
-            <a:ext cx="1755648" cy="1417320"/>
+            <a:off x="603504" y="2212848"/>
+            <a:ext cx="1481328" cy="1481328"/>
           </a:xfrm>
           <a:prstGeom prst="rect">
             <a:avLst/>
@@ -12939,8 +12956,8 @@
         </p:nvSpPr>
         <p:spPr>
           <a:xfrm>
-            <a:off x="713232" y="2212848"/>
-            <a:ext cx="50292" cy="1417320"/>
+            <a:off x="603504" y="2212848"/>
+            <a:ext cx="50292" cy="1481328"/>
           </a:xfrm>
           <a:prstGeom prst="rect">
             <a:avLst/>
@@ -12966,8 +12983,8 @@
         </p:nvSpPr>
         <p:spPr>
           <a:xfrm>
-            <a:off x="877824" y="2368296"/>
-            <a:ext cx="1426464" cy="292608"/>
+            <a:off x="768096" y="2368296"/>
+            <a:ext cx="1152144" cy="292608"/>
           </a:xfrm>
           <a:prstGeom prst="rect">
             <a:avLst/>
@@ -13007,26 +13024,26 @@
         </p:nvSpPr>
         <p:spPr>
           <a:xfrm>
-            <a:off x="877824" y="2734056"/>
-            <a:ext cx="1426464" cy="804672"/>
-          </a:xfrm>
-          <a:prstGeom prst="rect">
-            <a:avLst/>
-          </a:prstGeom>
-          <a:noFill/>
-          <a:ln/>
-        </p:spPr>
-        <p:txBody>
-          <a:bodyPr wrap="square" lIns="635" tIns="635" rIns="635" bIns="635" rtlCol="0" anchor="t">
-            <a:normAutofit/>
-          </a:bodyPr>
-          <a:lstStyle/>
-          <a:p>
-            <a:pPr algn="l" indent="0" marL="0">
-              <a:buNone/>
-            </a:pPr>
-            <a:r>
-              <a:rPr lang="en-US" sz="1000" dirty="0">
+            <a:off x="768096" y="2734056"/>
+            <a:ext cx="1152144" cy="868680"/>
+          </a:xfrm>
+          <a:prstGeom prst="rect">
+            <a:avLst/>
+          </a:prstGeom>
+          <a:noFill/>
+          <a:ln/>
+        </p:spPr>
+        <p:txBody>
+          <a:bodyPr wrap="square" lIns="635" tIns="635" rIns="635" bIns="635" rtlCol="0" anchor="t">
+            <a:normAutofit/>
+          </a:bodyPr>
+          <a:lstStyle/>
+          <a:p>
+            <a:pPr algn="l" indent="0" marL="0">
+              <a:buNone/>
+            </a:pPr>
+            <a:r>
+              <a:rPr lang="en-US" sz="880" dirty="0">
                 <a:solidFill>
                   <a:srgbClr val="94A3B8"/>
                 </a:solidFill>
@@ -13036,7 +13053,7 @@
               </a:rPr>
               <a:t>Issue、Git、依赖、配置、流量、告警</a:t>
             </a:r>
-            <a:endParaRPr lang="en-US" sz="1000" dirty="0"/>
+            <a:endParaRPr lang="en-US" sz="880" dirty="0"/>
           </a:p>
         </p:txBody>
       </p:sp>
@@ -13048,8 +13065,8 @@
         </p:nvSpPr>
         <p:spPr>
           <a:xfrm>
-            <a:off x="2523744" y="2651760"/>
-            <a:ext cx="347472" cy="274320"/>
+            <a:off x="2121408" y="2670048"/>
+            <a:ext cx="256032" cy="274320"/>
           </a:xfrm>
           <a:prstGeom prst="rect">
             <a:avLst/>
@@ -13067,7 +13084,7 @@
               <a:buNone/>
             </a:pPr>
             <a:r>
-              <a:rPr lang="en-US" sz="2000" b="1" dirty="0">
+              <a:rPr lang="en-US" sz="1700" b="1" dirty="0">
                 <a:solidFill>
                   <a:srgbClr val="94A3B8"/>
                 </a:solidFill>
@@ -13077,7 +13094,7 @@
               </a:rPr>
               <a:t>→</a:t>
             </a:r>
-            <a:endParaRPr lang="en-US" sz="2000" dirty="0"/>
+            <a:endParaRPr lang="en-US" sz="1700" dirty="0"/>
           </a:p>
         </p:txBody>
       </p:sp>
@@ -13089,8 +13106,8 @@
         </p:nvSpPr>
         <p:spPr>
           <a:xfrm>
-            <a:off x="2953512" y="2212848"/>
-            <a:ext cx="1755648" cy="1417320"/>
+            <a:off x="2414016" y="2212848"/>
+            <a:ext cx="1481328" cy="1481328"/>
           </a:xfrm>
           <a:prstGeom prst="rect">
             <a:avLst/>
@@ -13114,8 +13131,8 @@
         </p:nvSpPr>
         <p:spPr>
           <a:xfrm>
-            <a:off x="2953512" y="2212848"/>
-            <a:ext cx="50292" cy="1417320"/>
+            <a:off x="2414016" y="2212848"/>
+            <a:ext cx="50292" cy="1481328"/>
           </a:xfrm>
           <a:prstGeom prst="rect">
             <a:avLst/>
@@ -13141,8 +13158,8 @@
         </p:nvSpPr>
         <p:spPr>
           <a:xfrm>
-            <a:off x="3118104" y="2368296"/>
-            <a:ext cx="1426464" cy="292608"/>
+            <a:off x="2578608" y="2368296"/>
+            <a:ext cx="1152144" cy="292608"/>
           </a:xfrm>
           <a:prstGeom prst="rect">
             <a:avLst/>
@@ -13182,36 +13199,36 @@
         </p:nvSpPr>
         <p:spPr>
           <a:xfrm>
-            <a:off x="3118104" y="2734056"/>
-            <a:ext cx="1426464" cy="804672"/>
-          </a:xfrm>
-          <a:prstGeom prst="rect">
-            <a:avLst/>
-          </a:prstGeom>
-          <a:noFill/>
-          <a:ln/>
-        </p:spPr>
-        <p:txBody>
-          <a:bodyPr wrap="square" lIns="635" tIns="635" rIns="635" bIns="635" rtlCol="0" anchor="t">
-            <a:normAutofit/>
-          </a:bodyPr>
-          <a:lstStyle/>
-          <a:p>
-            <a:pPr algn="l" indent="0" marL="0">
-              <a:buNone/>
-            </a:pPr>
-            <a:r>
-              <a:rPr lang="en-US" sz="1000" dirty="0">
-                <a:solidFill>
-                  <a:srgbClr val="94A3B8"/>
-                </a:solidFill>
-                <a:latin typeface="Microsoft YaHei" pitchFamily="34" charset="0"/>
-                <a:ea typeface="Microsoft YaHei" pitchFamily="34" charset="-122"/>
-                <a:cs typeface="Microsoft YaHei" pitchFamily="34" charset="-120"/>
-              </a:rPr>
-              <a:t>撤销可疑变更，在平行版本中重放事故</a:t>
-            </a:r>
-            <a:endParaRPr lang="en-US" sz="1000" dirty="0"/>
+            <a:off x="2578608" y="2734056"/>
+            <a:ext cx="1152144" cy="868680"/>
+          </a:xfrm>
+          <a:prstGeom prst="rect">
+            <a:avLst/>
+          </a:prstGeom>
+          <a:noFill/>
+          <a:ln/>
+        </p:spPr>
+        <p:txBody>
+          <a:bodyPr wrap="square" lIns="635" tIns="635" rIns="635" bIns="635" rtlCol="0" anchor="t">
+            <a:normAutofit/>
+          </a:bodyPr>
+          <a:lstStyle/>
+          <a:p>
+            <a:pPr algn="l" indent="0" marL="0">
+              <a:buNone/>
+            </a:pPr>
+            <a:r>
+              <a:rPr lang="en-US" sz="880" dirty="0">
+                <a:solidFill>
+                  <a:srgbClr val="94A3B8"/>
+                </a:solidFill>
+                <a:latin typeface="Microsoft YaHei" pitchFamily="34" charset="0"/>
+                <a:ea typeface="Microsoft YaHei" pitchFamily="34" charset="-122"/>
+                <a:cs typeface="Microsoft YaHei" pitchFamily="34" charset="-120"/>
+              </a:rPr>
+              <a:t>撤销可疑变更，重放事故证明根因</a:t>
+            </a:r>
+            <a:endParaRPr lang="en-US" sz="880" dirty="0"/>
           </a:p>
         </p:txBody>
       </p:sp>
@@ -13223,8 +13240,8 @@
         </p:nvSpPr>
         <p:spPr>
           <a:xfrm>
-            <a:off x="4764024" y="2651760"/>
-            <a:ext cx="347472" cy="274320"/>
+            <a:off x="3931920" y="2670048"/>
+            <a:ext cx="256032" cy="274320"/>
           </a:xfrm>
           <a:prstGeom prst="rect">
             <a:avLst/>
@@ -13242,7 +13259,7 @@
               <a:buNone/>
             </a:pPr>
             <a:r>
-              <a:rPr lang="en-US" sz="2000" b="1" dirty="0">
+              <a:rPr lang="en-US" sz="1700" b="1" dirty="0">
                 <a:solidFill>
                   <a:srgbClr val="94A3B8"/>
                 </a:solidFill>
@@ -13252,7 +13269,7 @@
               </a:rPr>
               <a:t>→</a:t>
             </a:r>
-            <a:endParaRPr lang="en-US" sz="2000" dirty="0"/>
+            <a:endParaRPr lang="en-US" sz="1700" dirty="0"/>
           </a:p>
         </p:txBody>
       </p:sp>
@@ -13264,8 +13281,8 @@
         </p:nvSpPr>
         <p:spPr>
           <a:xfrm>
-            <a:off x="5193792" y="2212848"/>
-            <a:ext cx="1755648" cy="1417320"/>
+            <a:off x="4224528" y="2212848"/>
+            <a:ext cx="1481328" cy="1481328"/>
           </a:xfrm>
           <a:prstGeom prst="rect">
             <a:avLst/>
@@ -13289,8 +13306,8 @@
         </p:nvSpPr>
         <p:spPr>
           <a:xfrm>
-            <a:off x="5193792" y="2212848"/>
-            <a:ext cx="50292" cy="1417320"/>
+            <a:off x="4224528" y="2212848"/>
+            <a:ext cx="50292" cy="1481328"/>
           </a:xfrm>
           <a:prstGeom prst="rect">
             <a:avLst/>
@@ -13316,8 +13333,8 @@
         </p:nvSpPr>
         <p:spPr>
           <a:xfrm>
-            <a:off x="5358384" y="2368296"/>
-            <a:ext cx="1426464" cy="292608"/>
+            <a:off x="4389120" y="2368296"/>
+            <a:ext cx="1152144" cy="292608"/>
           </a:xfrm>
           <a:prstGeom prst="rect">
             <a:avLst/>
@@ -13343,7 +13360,7 @@
                 <a:ea typeface="Microsoft YaHei" pitchFamily="34" charset="-122"/>
                 <a:cs typeface="Microsoft YaHei" pitchFamily="34" charset="-120"/>
               </a:rPr>
-              <a:t>补丁竞赛</a:t>
+              <a:t>缺陷基因</a:t>
             </a:r>
             <a:endParaRPr lang="en-US" sz="1500" dirty="0"/>
           </a:p>
@@ -13357,36 +13374,36 @@
         </p:nvSpPr>
         <p:spPr>
           <a:xfrm>
-            <a:off x="5358384" y="2734056"/>
-            <a:ext cx="1426464" cy="804672"/>
-          </a:xfrm>
-          <a:prstGeom prst="rect">
-            <a:avLst/>
-          </a:prstGeom>
-          <a:noFill/>
-          <a:ln/>
-        </p:spPr>
-        <p:txBody>
-          <a:bodyPr wrap="square" lIns="635" tIns="635" rIns="635" bIns="635" rtlCol="0" anchor="t">
-            <a:normAutofit/>
-          </a:bodyPr>
-          <a:lstStyle/>
-          <a:p>
-            <a:pPr algn="l" indent="0" marL="0">
-              <a:buNone/>
-            </a:pPr>
-            <a:r>
-              <a:rPr lang="en-US" sz="1000" dirty="0">
-                <a:solidFill>
-                  <a:srgbClr val="94A3B8"/>
-                </a:solidFill>
-                <a:latin typeface="Microsoft YaHei" pitchFamily="34" charset="0"/>
-                <a:ea typeface="Microsoft YaHei" pitchFamily="34" charset="-122"/>
-                <a:cs typeface="Microsoft YaHei" pitchFamily="34" charset="-120"/>
-              </a:rPr>
-              <a:t>候选方案在缺陷基因变体上对抗验证</a:t>
-            </a:r>
-            <a:endParaRPr lang="en-US" sz="1000" dirty="0"/>
+            <a:off x="4389120" y="2734056"/>
+            <a:ext cx="1152144" cy="868680"/>
+          </a:xfrm>
+          <a:prstGeom prst="rect">
+            <a:avLst/>
+          </a:prstGeom>
+          <a:noFill/>
+          <a:ln/>
+        </p:spPr>
+        <p:txBody>
+          <a:bodyPr wrap="square" lIns="635" tIns="635" rIns="635" bIns="635" rtlCol="0" anchor="t">
+            <a:normAutofit/>
+          </a:bodyPr>
+          <a:lstStyle/>
+          <a:p>
+            <a:pPr algn="l" indent="0" marL="0">
+              <a:buNone/>
+            </a:pPr>
+            <a:r>
+              <a:rPr lang="en-US" sz="880" dirty="0">
+                <a:solidFill>
+                  <a:srgbClr val="94A3B8"/>
+                </a:solidFill>
+                <a:latin typeface="Microsoft YaHei" pitchFamily="34" charset="0"/>
+                <a:ea typeface="Microsoft YaHei" pitchFamily="34" charset="-122"/>
+                <a:cs typeface="Microsoft YaHei" pitchFamily="34" charset="-120"/>
+              </a:rPr>
+              <a:t>一组同源变体验证补丁鲁棒性</a:t>
+            </a:r>
+            <a:endParaRPr lang="en-US" sz="880" dirty="0"/>
           </a:p>
         </p:txBody>
       </p:sp>
@@ -13398,8 +13415,8 @@
         </p:nvSpPr>
         <p:spPr>
           <a:xfrm>
-            <a:off x="7004304" y="2651760"/>
-            <a:ext cx="347472" cy="274320"/>
+            <a:off x="5742432" y="2670048"/>
+            <a:ext cx="256032" cy="274320"/>
           </a:xfrm>
           <a:prstGeom prst="rect">
             <a:avLst/>
@@ -13417,7 +13434,7 @@
               <a:buNone/>
             </a:pPr>
             <a:r>
-              <a:rPr lang="en-US" sz="2000" b="1" dirty="0">
+              <a:rPr lang="en-US" sz="1700" b="1" dirty="0">
                 <a:solidFill>
                   <a:srgbClr val="94A3B8"/>
                 </a:solidFill>
@@ -13427,7 +13444,7 @@
               </a:rPr>
               <a:t>→</a:t>
             </a:r>
-            <a:endParaRPr lang="en-US" sz="2000" dirty="0"/>
+            <a:endParaRPr lang="en-US" sz="1700" dirty="0"/>
           </a:p>
         </p:txBody>
       </p:sp>
@@ -13439,8 +13456,8 @@
         </p:nvSpPr>
         <p:spPr>
           <a:xfrm>
-            <a:off x="7434072" y="2212848"/>
-            <a:ext cx="1755648" cy="1417320"/>
+            <a:off x="6035040" y="2212848"/>
+            <a:ext cx="1481328" cy="1481328"/>
           </a:xfrm>
           <a:prstGeom prst="rect">
             <a:avLst/>
@@ -13464,8 +13481,8 @@
         </p:nvSpPr>
         <p:spPr>
           <a:xfrm>
-            <a:off x="7434072" y="2212848"/>
-            <a:ext cx="50292" cy="1417320"/>
+            <a:off x="6035040" y="2212848"/>
+            <a:ext cx="50292" cy="1481328"/>
           </a:xfrm>
           <a:prstGeom prst="rect">
             <a:avLst/>
@@ -13491,8 +13508,8 @@
         </p:nvSpPr>
         <p:spPr>
           <a:xfrm>
-            <a:off x="7598664" y="2368296"/>
-            <a:ext cx="1426464" cy="292608"/>
+            <a:off x="6199632" y="2368296"/>
+            <a:ext cx="1152144" cy="292608"/>
           </a:xfrm>
           <a:prstGeom prst="rect">
             <a:avLst/>
@@ -13518,7 +13535,7 @@
                 <a:ea typeface="Microsoft YaHei" pitchFamily="34" charset="-122"/>
                 <a:cs typeface="Microsoft YaHei" pitchFamily="34" charset="-120"/>
               </a:rPr>
-              <a:t>证据护照</a:t>
+              <a:t>RiskGate</a:t>
             </a:r>
             <a:endParaRPr lang="en-US" sz="1500" dirty="0"/>
           </a:p>
@@ -13532,36 +13549,36 @@
         </p:nvSpPr>
         <p:spPr>
           <a:xfrm>
-            <a:off x="7598664" y="2734056"/>
-            <a:ext cx="1426464" cy="804672"/>
-          </a:xfrm>
-          <a:prstGeom prst="rect">
-            <a:avLst/>
-          </a:prstGeom>
-          <a:noFill/>
-          <a:ln/>
-        </p:spPr>
-        <p:txBody>
-          <a:bodyPr wrap="square" lIns="635" tIns="635" rIns="635" bIns="635" rtlCol="0" anchor="t">
-            <a:normAutofit/>
-          </a:bodyPr>
-          <a:lstStyle/>
-          <a:p>
-            <a:pPr algn="l" indent="0" marL="0">
-              <a:buNone/>
-            </a:pPr>
-            <a:r>
-              <a:rPr lang="en-US" sz="1000" dirty="0">
-                <a:solidFill>
-                  <a:srgbClr val="94A3B8"/>
-                </a:solidFill>
-                <a:latin typeface="Microsoft YaHei" pitchFamily="34" charset="0"/>
-                <a:ea typeface="Microsoft YaHei" pitchFamily="34" charset="-122"/>
-                <a:cs typeface="Microsoft YaHei" pitchFamily="34" charset="-120"/>
-              </a:rPr>
-              <a:t>因果、验证、风险、回滚和缺口声明</a:t>
-            </a:r>
-            <a:endParaRPr lang="en-US" sz="1000" dirty="0"/>
+            <a:off x="6199632" y="2734056"/>
+            <a:ext cx="1152144" cy="868680"/>
+          </a:xfrm>
+          <a:prstGeom prst="rect">
+            <a:avLst/>
+          </a:prstGeom>
+          <a:noFill/>
+          <a:ln/>
+        </p:spPr>
+        <p:txBody>
+          <a:bodyPr wrap="square" lIns="635" tIns="635" rIns="635" bIns="635" rtlCol="0" anchor="t">
+            <a:normAutofit/>
+          </a:bodyPr>
+          <a:lstStyle/>
+          <a:p>
+            <a:pPr algn="l" indent="0" marL="0">
+              <a:buNone/>
+            </a:pPr>
+            <a:r>
+              <a:rPr lang="en-US" sz="880" dirty="0">
+                <a:solidFill>
+                  <a:srgbClr val="94A3B8"/>
+                </a:solidFill>
+                <a:latin typeface="Microsoft YaHei" pitchFamily="34" charset="0"/>
+                <a:ea typeface="Microsoft YaHei" pitchFamily="34" charset="-122"/>
+                <a:cs typeface="Microsoft YaHei" pitchFamily="34" charset="-120"/>
+              </a:rPr>
+              <a:t>中高风险动作必须审批与回滚</a:t>
+            </a:r>
+            <a:endParaRPr lang="en-US" sz="880" dirty="0"/>
           </a:p>
         </p:txBody>
       </p:sp>
@@ -13573,8 +13590,8 @@
         </p:nvSpPr>
         <p:spPr>
           <a:xfrm>
-            <a:off x="9244584" y="2651760"/>
-            <a:ext cx="347472" cy="274320"/>
+            <a:off x="7552944" y="2670048"/>
+            <a:ext cx="256032" cy="274320"/>
           </a:xfrm>
           <a:prstGeom prst="rect">
             <a:avLst/>
@@ -13592,7 +13609,7 @@
               <a:buNone/>
             </a:pPr>
             <a:r>
-              <a:rPr lang="en-US" sz="2000" b="1" dirty="0">
+              <a:rPr lang="en-US" sz="1700" b="1" dirty="0">
                 <a:solidFill>
                   <a:srgbClr val="94A3B8"/>
                 </a:solidFill>
@@ -13602,7 +13619,7 @@
               </a:rPr>
               <a:t>→</a:t>
             </a:r>
-            <a:endParaRPr lang="en-US" sz="2000" dirty="0"/>
+            <a:endParaRPr lang="en-US" sz="1700" dirty="0"/>
           </a:p>
         </p:txBody>
       </p:sp>
@@ -13614,8 +13631,8 @@
         </p:nvSpPr>
         <p:spPr>
           <a:xfrm>
-            <a:off x="9674352" y="2212848"/>
-            <a:ext cx="1755648" cy="1417320"/>
+            <a:off x="7845552" y="2212848"/>
+            <a:ext cx="1481328" cy="1481328"/>
           </a:xfrm>
           <a:prstGeom prst="rect">
             <a:avLst/>
@@ -13639,8 +13656,8 @@
         </p:nvSpPr>
         <p:spPr>
           <a:xfrm>
-            <a:off x="9674352" y="2212848"/>
-            <a:ext cx="50292" cy="1417320"/>
+            <a:off x="7845552" y="2212848"/>
+            <a:ext cx="50292" cy="1481328"/>
           </a:xfrm>
           <a:prstGeom prst="rect">
             <a:avLst/>
@@ -13666,8 +13683,8 @@
         </p:nvSpPr>
         <p:spPr>
           <a:xfrm>
-            <a:off x="9838944" y="2368296"/>
-            <a:ext cx="1426464" cy="292608"/>
+            <a:off x="8010144" y="2368296"/>
+            <a:ext cx="1152144" cy="292608"/>
           </a:xfrm>
           <a:prstGeom prst="rect">
             <a:avLst/>
@@ -13693,6 +13710,181 @@
                 <a:ea typeface="Microsoft YaHei" pitchFamily="34" charset="-122"/>
                 <a:cs typeface="Microsoft YaHei" pitchFamily="34" charset="-120"/>
               </a:rPr>
+              <a:t>PR 证据护照</a:t>
+            </a:r>
+            <a:endParaRPr lang="en-US" sz="1500" dirty="0"/>
+          </a:p>
+        </p:txBody>
+      </p:sp>
+      <p:sp>
+        <p:nvSpPr>
+          <p:cNvPr id="32" name="Text 30"/>
+          <p:cNvSpPr/>
+          <p:nvPr/>
+        </p:nvSpPr>
+        <p:spPr>
+          <a:xfrm>
+            <a:off x="8010144" y="2734056"/>
+            <a:ext cx="1152144" cy="868680"/>
+          </a:xfrm>
+          <a:prstGeom prst="rect">
+            <a:avLst/>
+          </a:prstGeom>
+          <a:noFill/>
+          <a:ln/>
+        </p:spPr>
+        <p:txBody>
+          <a:bodyPr wrap="square" lIns="635" tIns="635" rIns="635" bIns="635" rtlCol="0" anchor="t">
+            <a:normAutofit/>
+          </a:bodyPr>
+          <a:lstStyle/>
+          <a:p>
+            <a:pPr algn="l" indent="0" marL="0">
+              <a:buNone/>
+            </a:pPr>
+            <a:r>
+              <a:rPr lang="en-US" sz="880" dirty="0">
+                <a:solidFill>
+                  <a:srgbClr val="94A3B8"/>
+                </a:solidFill>
+                <a:latin typeface="Microsoft YaHei" pitchFamily="34" charset="0"/>
+                <a:ea typeface="Microsoft YaHei" pitchFamily="34" charset="-122"/>
+                <a:cs typeface="Microsoft YaHei" pitchFamily="34" charset="-120"/>
+              </a:rPr>
+              <a:t>diff、checks、因果、验证、风险声明</a:t>
+            </a:r>
+            <a:endParaRPr lang="en-US" sz="880" dirty="0"/>
+          </a:p>
+        </p:txBody>
+      </p:sp>
+      <p:sp>
+        <p:nvSpPr>
+          <p:cNvPr id="33" name="Text 31"/>
+          <p:cNvSpPr/>
+          <p:nvPr/>
+        </p:nvSpPr>
+        <p:spPr>
+          <a:xfrm>
+            <a:off x="9363456" y="2670048"/>
+            <a:ext cx="256032" cy="274320"/>
+          </a:xfrm>
+          <a:prstGeom prst="rect">
+            <a:avLst/>
+          </a:prstGeom>
+          <a:noFill/>
+          <a:ln/>
+        </p:spPr>
+        <p:txBody>
+          <a:bodyPr wrap="square" lIns="635" tIns="635" rIns="635" bIns="635" rtlCol="0" anchor="t">
+            <a:normAutofit/>
+          </a:bodyPr>
+          <a:lstStyle/>
+          <a:p>
+            <a:pPr algn="ctr" indent="0" marL="0">
+              <a:buNone/>
+            </a:pPr>
+            <a:r>
+              <a:rPr lang="en-US" sz="1700" b="1" dirty="0">
+                <a:solidFill>
+                  <a:srgbClr val="94A3B8"/>
+                </a:solidFill>
+                <a:latin typeface="Microsoft YaHei" pitchFamily="34" charset="0"/>
+                <a:ea typeface="Microsoft YaHei" pitchFamily="34" charset="-122"/>
+                <a:cs typeface="Microsoft YaHei" pitchFamily="34" charset="-120"/>
+              </a:rPr>
+              <a:t>→</a:t>
+            </a:r>
+            <a:endParaRPr lang="en-US" sz="1700" dirty="0"/>
+          </a:p>
+        </p:txBody>
+      </p:sp>
+      <p:sp>
+        <p:nvSpPr>
+          <p:cNvPr id="34" name="Shape 32"/>
+          <p:cNvSpPr/>
+          <p:nvPr/>
+        </p:nvSpPr>
+        <p:spPr>
+          <a:xfrm>
+            <a:off x="9656064" y="2212848"/>
+            <a:ext cx="1481328" cy="1481328"/>
+          </a:xfrm>
+          <a:prstGeom prst="rect">
+            <a:avLst/>
+          </a:prstGeom>
+          <a:solidFill>
+            <a:srgbClr val="111827"/>
+          </a:solidFill>
+          <a:ln w="12700">
+            <a:solidFill>
+              <a:srgbClr val="334155"/>
+            </a:solidFill>
+            <a:prstDash val="solid"/>
+          </a:ln>
+        </p:spPr>
+      </p:sp>
+      <p:sp>
+        <p:nvSpPr>
+          <p:cNvPr id="35" name="Shape 33"/>
+          <p:cNvSpPr/>
+          <p:nvPr/>
+        </p:nvSpPr>
+        <p:spPr>
+          <a:xfrm>
+            <a:off x="9656064" y="2212848"/>
+            <a:ext cx="50292" cy="1481328"/>
+          </a:xfrm>
+          <a:prstGeom prst="rect">
+            <a:avLst/>
+          </a:prstGeom>
+          <a:solidFill>
+            <a:srgbClr val="22D3EE"/>
+          </a:solidFill>
+          <a:ln w="12700">
+            <a:solidFill>
+              <a:srgbClr val="22D3EE">
+                <a:alpha val="0"/>
+              </a:srgbClr>
+            </a:solidFill>
+            <a:prstDash val="solid"/>
+          </a:ln>
+        </p:spPr>
+      </p:sp>
+      <p:sp>
+        <p:nvSpPr>
+          <p:cNvPr id="36" name="Text 34"/>
+          <p:cNvSpPr/>
+          <p:nvPr/>
+        </p:nvSpPr>
+        <p:spPr>
+          <a:xfrm>
+            <a:off x="9820656" y="2368296"/>
+            <a:ext cx="1152144" cy="292608"/>
+          </a:xfrm>
+          <a:prstGeom prst="rect">
+            <a:avLst/>
+          </a:prstGeom>
+          <a:noFill/>
+          <a:ln/>
+        </p:spPr>
+        <p:txBody>
+          <a:bodyPr wrap="square" lIns="635" tIns="635" rIns="635" bIns="635" rtlCol="0" anchor="t">
+            <a:normAutofit/>
+          </a:bodyPr>
+          <a:lstStyle/>
+          <a:p>
+            <a:pPr algn="l" indent="0" marL="0">
+              <a:buNone/>
+            </a:pPr>
+            <a:r>
+              <a:rPr lang="en-US" sz="1500" b="1" dirty="0">
+                <a:solidFill>
+                  <a:srgbClr val="FFFFFF"/>
+                </a:solidFill>
+                <a:latin typeface="Microsoft YaHei" pitchFamily="34" charset="0"/>
+                <a:ea typeface="Microsoft YaHei" pitchFamily="34" charset="-122"/>
+                <a:cs typeface="Microsoft YaHei" pitchFamily="34" charset="-120"/>
+              </a:rPr>
               <a:t>资产沉淀</a:t>
             </a:r>
             <a:endParaRPr lang="en-US" sz="1500" dirty="0"/>
@@ -13701,32 +13893,32 @@
       </p:sp>
       <p:sp>
         <p:nvSpPr>
-          <p:cNvPr id="32" name="Text 30"/>
-          <p:cNvSpPr/>
-          <p:nvPr/>
-        </p:nvSpPr>
-        <p:spPr>
-          <a:xfrm>
-            <a:off x="9838944" y="2734056"/>
-            <a:ext cx="1426464" cy="804672"/>
-          </a:xfrm>
-          <a:prstGeom prst="rect">
-            <a:avLst/>
-          </a:prstGeom>
-          <a:noFill/>
-          <a:ln/>
-        </p:spPr>
-        <p:txBody>
-          <a:bodyPr wrap="square" lIns="635" tIns="635" rIns="635" bIns="635" rtlCol="0" anchor="t">
-            <a:normAutofit/>
-          </a:bodyPr>
-          <a:lstStyle/>
-          <a:p>
-            <a:pPr algn="l" indent="0" marL="0">
-              <a:buNone/>
-            </a:pPr>
-            <a:r>
-              <a:rPr lang="en-US" sz="1000" dirty="0">
+          <p:cNvPr id="37" name="Text 35"/>
+          <p:cNvSpPr/>
+          <p:nvPr/>
+        </p:nvSpPr>
+        <p:spPr>
+          <a:xfrm>
+            <a:off x="9820656" y="2734056"/>
+            <a:ext cx="1152144" cy="868680"/>
+          </a:xfrm>
+          <a:prstGeom prst="rect">
+            <a:avLst/>
+          </a:prstGeom>
+          <a:noFill/>
+          <a:ln/>
+        </p:spPr>
+        <p:txBody>
+          <a:bodyPr wrap="square" lIns="635" tIns="635" rIns="635" bIns="635" rtlCol="0" anchor="t">
+            <a:normAutofit/>
+          </a:bodyPr>
+          <a:lstStyle/>
+          <a:p>
+            <a:pPr algn="l" indent="0" marL="0">
+              <a:buNone/>
+            </a:pPr>
+            <a:r>
+              <a:rPr lang="en-US" sz="880" dirty="0">
                 <a:solidFill>
                   <a:srgbClr val="94A3B8"/>
                 </a:solidFill>
@@ -13736,19 +13928,19 @@
               </a:rPr>
               <a:t>故障基因包、证据模板、可复用 Skill</a:t>
             </a:r>
-            <a:endParaRPr lang="en-US" sz="1000" dirty="0"/>
-          </a:p>
-        </p:txBody>
-      </p:sp>
-      <p:sp>
-        <p:nvSpPr>
-          <p:cNvPr id="33" name="Shape 31"/>
-          <p:cNvSpPr/>
-          <p:nvPr/>
-        </p:nvSpPr>
-        <p:spPr>
-          <a:xfrm>
-            <a:off x="960120" y="4279392"/>
+            <a:endParaRPr lang="en-US" sz="880" dirty="0"/>
+          </a:p>
+        </p:txBody>
+      </p:sp>
+      <p:sp>
+        <p:nvSpPr>
+          <p:cNvPr id="38" name="Shape 36"/>
+          <p:cNvSpPr/>
+          <p:nvPr/>
+        </p:nvSpPr>
+        <p:spPr>
+          <a:xfrm>
+            <a:off x="960120" y="4315968"/>
             <a:ext cx="2468880" cy="987552"/>
           </a:xfrm>
           <a:prstGeom prst="rect">
@@ -13767,13 +13959,13 @@
       </p:sp>
       <p:sp>
         <p:nvSpPr>
-          <p:cNvPr id="34" name="Text 32"/>
-          <p:cNvSpPr/>
-          <p:nvPr/>
-        </p:nvSpPr>
-        <p:spPr>
-          <a:xfrm>
-            <a:off x="1097280" y="4425696"/>
+          <p:cNvPr id="39" name="Text 37"/>
+          <p:cNvSpPr/>
+          <p:nvPr/>
+        </p:nvSpPr>
+        <p:spPr>
+          <a:xfrm>
+            <a:off x="1097280" y="4462272"/>
             <a:ext cx="2194560" cy="329184"/>
           </a:xfrm>
           <a:prstGeom prst="rect">
@@ -13800,7 +13992,7 @@
                 <a:ea typeface="Microsoft YaHei" pitchFamily="34" charset="-122"/>
                 <a:cs typeface="Microsoft YaHei" pitchFamily="34" charset="-120"/>
               </a:rPr>
-              <a:t>3类</a:t>
+              <a:t>6环</a:t>
             </a:r>
             <a:endParaRPr lang="en-US" sz="2200" dirty="0"/>
           </a:p>
@@ -13808,13 +14000,13 @@
       </p:sp>
       <p:sp>
         <p:nvSpPr>
-          <p:cNvPr id="35" name="Text 33"/>
-          <p:cNvSpPr/>
-          <p:nvPr/>
-        </p:nvSpPr>
-        <p:spPr>
-          <a:xfrm>
-            <a:off x="1097280" y="4800600"/>
+          <p:cNvPr id="40" name="Text 38"/>
+          <p:cNvSpPr/>
+          <p:nvPr/>
+        </p:nvSpPr>
+        <p:spPr>
+          <a:xfrm>
+            <a:off x="1097280" y="4837176"/>
             <a:ext cx="2194560" cy="228600"/>
           </a:xfrm>
           <a:prstGeom prst="rect">
@@ -13841,7 +14033,7 @@
                 <a:ea typeface="Microsoft YaHei" pitchFamily="34" charset="-122"/>
                 <a:cs typeface="Microsoft YaHei" pitchFamily="34" charset="-120"/>
               </a:rPr>
-              <a:t>质量资产</a:t>
+              <a:t>证明链</a:t>
             </a:r>
             <a:endParaRPr lang="en-US" sz="1150" dirty="0"/>
           </a:p>
@@ -13849,13 +14041,13 @@
       </p:sp>
       <p:sp>
         <p:nvSpPr>
-          <p:cNvPr id="36" name="Text 34"/>
-          <p:cNvSpPr/>
-          <p:nvPr/>
-        </p:nvSpPr>
-        <p:spPr>
-          <a:xfrm>
-            <a:off x="1097280" y="5047488"/>
+          <p:cNvPr id="41" name="Text 39"/>
+          <p:cNvSpPr/>
+          <p:nvPr/>
+        </p:nvSpPr>
+        <p:spPr>
+          <a:xfrm>
+            <a:off x="1097280" y="5084064"/>
             <a:ext cx="2194560" cy="164592"/>
           </a:xfrm>
           <a:prstGeom prst="rect">
@@ -13882,7 +14074,7 @@
                 <a:ea typeface="Microsoft YaHei" pitchFamily="34" charset="-122"/>
                 <a:cs typeface="Microsoft YaHei" pitchFamily="34" charset="-120"/>
               </a:rPr>
-              <a:t>Patch / Gene / Passport</a:t>
+              <a:t>Evidence → Skill</a:t>
             </a:r>
             <a:endParaRPr lang="en-US" sz="850" dirty="0"/>
           </a:p>
@@ -13890,13 +14082,13 @@
       </p:sp>
       <p:sp>
         <p:nvSpPr>
-          <p:cNvPr id="37" name="Shape 35"/>
-          <p:cNvSpPr/>
-          <p:nvPr/>
-        </p:nvSpPr>
-        <p:spPr>
-          <a:xfrm>
-            <a:off x="3822192" y="4279392"/>
+          <p:cNvPr id="42" name="Shape 40"/>
+          <p:cNvSpPr/>
+          <p:nvPr/>
+        </p:nvSpPr>
+        <p:spPr>
+          <a:xfrm>
+            <a:off x="3822192" y="4315968"/>
             <a:ext cx="2468880" cy="987552"/>
           </a:xfrm>
           <a:prstGeom prst="rect">
@@ -13915,13 +14107,13 @@
       </p:sp>
       <p:sp>
         <p:nvSpPr>
-          <p:cNvPr id="38" name="Text 36"/>
-          <p:cNvSpPr/>
-          <p:nvPr/>
-        </p:nvSpPr>
-        <p:spPr>
-          <a:xfrm>
-            <a:off x="3959352" y="4425696"/>
+          <p:cNvPr id="43" name="Text 41"/>
+          <p:cNvSpPr/>
+          <p:nvPr/>
+        </p:nvSpPr>
+        <p:spPr>
+          <a:xfrm>
+            <a:off x="3959352" y="4462272"/>
             <a:ext cx="2194560" cy="329184"/>
           </a:xfrm>
           <a:prstGeom prst="rect">
@@ -13956,13 +14148,13 @@
       </p:sp>
       <p:sp>
         <p:nvSpPr>
-          <p:cNvPr id="39" name="Text 37"/>
-          <p:cNvSpPr/>
-          <p:nvPr/>
-        </p:nvSpPr>
-        <p:spPr>
-          <a:xfrm>
-            <a:off x="3959352" y="4800600"/>
+          <p:cNvPr id="44" name="Text 42"/>
+          <p:cNvSpPr/>
+          <p:nvPr/>
+        </p:nvSpPr>
+        <p:spPr>
+          <a:xfrm>
+            <a:off x="3959352" y="4837176"/>
             <a:ext cx="2194560" cy="228600"/>
           </a:xfrm>
           <a:prstGeom prst="rect">
@@ -13997,13 +14189,13 @@
       </p:sp>
       <p:sp>
         <p:nvSpPr>
-          <p:cNvPr id="40" name="Text 38"/>
-          <p:cNvSpPr/>
-          <p:nvPr/>
-        </p:nvSpPr>
-        <p:spPr>
-          <a:xfrm>
-            <a:off x="3959352" y="5047488"/>
+          <p:cNvPr id="45" name="Text 43"/>
+          <p:cNvSpPr/>
+          <p:nvPr/>
+        </p:nvSpPr>
+        <p:spPr>
+          <a:xfrm>
+            <a:off x="3959352" y="5084064"/>
             <a:ext cx="2194560" cy="164592"/>
           </a:xfrm>
           <a:prstGeom prst="rect">
@@ -14038,13 +14230,13 @@
       </p:sp>
       <p:sp>
         <p:nvSpPr>
-          <p:cNvPr id="41" name="Shape 39"/>
-          <p:cNvSpPr/>
-          <p:nvPr/>
-        </p:nvSpPr>
-        <p:spPr>
-          <a:xfrm>
-            <a:off x="6684264" y="4279392"/>
+          <p:cNvPr id="46" name="Shape 44"/>
+          <p:cNvSpPr/>
+          <p:nvPr/>
+        </p:nvSpPr>
+        <p:spPr>
+          <a:xfrm>
+            <a:off x="6684264" y="4315968"/>
             <a:ext cx="2468880" cy="987552"/>
           </a:xfrm>
           <a:prstGeom prst="rect">
@@ -14063,13 +14255,13 @@
       </p:sp>
       <p:sp>
         <p:nvSpPr>
-          <p:cNvPr id="42" name="Text 40"/>
-          <p:cNvSpPr/>
-          <p:nvPr/>
-        </p:nvSpPr>
-        <p:spPr>
-          <a:xfrm>
-            <a:off x="6821424" y="4425696"/>
+          <p:cNvPr id="47" name="Text 45"/>
+          <p:cNvSpPr/>
+          <p:nvPr/>
+        </p:nvSpPr>
+        <p:spPr>
+          <a:xfrm>
+            <a:off x="6821424" y="4462272"/>
             <a:ext cx="2194560" cy="329184"/>
           </a:xfrm>
           <a:prstGeom prst="rect">
@@ -14096,7 +14288,7 @@
                 <a:ea typeface="Microsoft YaHei" pitchFamily="34" charset="-122"/>
                 <a:cs typeface="Microsoft YaHei" pitchFamily="34" charset="-120"/>
               </a:rPr>
-              <a:t>0商业API</a:t>
+              <a:t>16段</a:t>
             </a:r>
             <a:endParaRPr lang="en-US" sz="2200" dirty="0"/>
           </a:p>
@@ -14104,13 +14296,13 @@
       </p:sp>
       <p:sp>
         <p:nvSpPr>
-          <p:cNvPr id="43" name="Text 41"/>
-          <p:cNvSpPr/>
-          <p:nvPr/>
-        </p:nvSpPr>
-        <p:spPr>
-          <a:xfrm>
-            <a:off x="6821424" y="4800600"/>
+          <p:cNvPr id="48" name="Text 46"/>
+          <p:cNvSpPr/>
+          <p:nvPr/>
+        </p:nvSpPr>
+        <p:spPr>
+          <a:xfrm>
+            <a:off x="6821424" y="4837176"/>
             <a:ext cx="2194560" cy="228600"/>
           </a:xfrm>
           <a:prstGeom prst="rect">
@@ -14137,7 +14329,7 @@
                 <a:ea typeface="Microsoft YaHei" pitchFamily="34" charset="-122"/>
                 <a:cs typeface="Microsoft YaHei" pitchFamily="34" charset="-120"/>
               </a:rPr>
-              <a:t>可复现核心</a:t>
+              <a:t>Trace Span</a:t>
             </a:r>
             <a:endParaRPr lang="en-US" sz="1150" dirty="0"/>
           </a:p>
@@ -14145,13 +14337,13 @@
       </p:sp>
       <p:sp>
         <p:nvSpPr>
-          <p:cNvPr id="44" name="Text 42"/>
-          <p:cNvSpPr/>
-          <p:nvPr/>
-        </p:nvSpPr>
-        <p:spPr>
-          <a:xfrm>
-            <a:off x="6821424" y="5047488"/>
+          <p:cNvPr id="49" name="Text 47"/>
+          <p:cNvSpPr/>
+          <p:nvPr/>
+        </p:nvSpPr>
+        <p:spPr>
+          <a:xfrm>
+            <a:off x="6821424" y="5084064"/>
             <a:ext cx="2194560" cy="164592"/>
           </a:xfrm>
           <a:prstGeom prst="rect">
@@ -14178,7 +14370,7 @@
                 <a:ea typeface="Microsoft YaHei" pitchFamily="34" charset="-122"/>
                 <a:cs typeface="Microsoft YaHei" pitchFamily="34" charset="-120"/>
               </a:rPr>
-              <a:t>合成数据 + 标准库</a:t>
+              <a:t>PR / checks included</a:t>
             </a:r>
             <a:endParaRPr lang="en-US" sz="850" dirty="0"/>
           </a:p>
@@ -14186,7 +14378,7 @@
       </p:sp>
       <p:sp>
         <p:nvSpPr>
-          <p:cNvPr id="45" name="Text 43"/>
+          <p:cNvPr id="50" name="Text 48"/>
           <p:cNvSpPr/>
           <p:nvPr/>
         </p:nvSpPr>
@@ -14443,7 +14635,7 @@
               <a:buNone/>
             </a:pPr>
             <a:r>
-              <a:rPr lang="en-US" sz="2600" b="1" dirty="0">
+              <a:rPr lang="en-US" sz="2450" b="1" dirty="0">
                 <a:solidFill>
                   <a:srgbClr val="FFFFFF"/>
                 </a:solidFill>
@@ -14451,9 +14643,9 @@
                 <a:ea typeface="Microsoft YaHei" pitchFamily="34" charset="-122"/>
                 <a:cs typeface="Microsoft YaHei" pitchFamily="34" charset="-120"/>
               </a:rPr>
-              <a:t>从故障输入到可审批补丁的端到端闭环</a:t>
-            </a:r>
-            <a:endParaRPr lang="en-US" sz="2600" dirty="0"/>
+              <a:t>从故障输入到 GitHub PR 证据护照的端到端闭环</a:t>
+            </a:r>
+            <a:endParaRPr lang="en-US" sz="2450" dirty="0"/>
           </a:p>
         </p:txBody>
       </p:sp>
@@ -14626,7 +14818,7 @@
                 <a:ea typeface="Microsoft YaHei" pitchFamily="34" charset="-122"/>
                 <a:cs typeface="Microsoft YaHei" pitchFamily="34" charset="-120"/>
               </a:rPr>
-              <a:t>• INC-2026-08-11</a:t>
+              <a:t>• INC-2026-0816-001</a:t>
             </a:r>
             <a:endParaRPr lang="en-US" sz="1150" dirty="0"/>
           </a:p>
@@ -14643,7 +14835,7 @@
                 <a:ea typeface="Microsoft YaHei" pitchFamily="34" charset="-122"/>
                 <a:cs typeface="Microsoft YaHei" pitchFamily="34" charset="-120"/>
               </a:rPr>
-              <a:t>• 退款状态异常</a:t>
+              <a:t>• 订单创建 5xx / P99 升高</a:t>
             </a:r>
             <a:endParaRPr lang="en-US" sz="1150" dirty="0"/>
           </a:p>
@@ -14677,7 +14869,7 @@
                 <a:ea typeface="Microsoft YaHei" pitchFamily="34" charset="-122"/>
                 <a:cs typeface="Microsoft YaHei" pitchFamily="34" charset="-120"/>
               </a:rPr>
-              <a:t>• synthetic order dataset</a:t>
+              <a:t>• synthetic checkout dataset</a:t>
             </a:r>
             <a:endParaRPr lang="en-US" sz="1150" dirty="0"/>
           </a:p>
@@ -15198,7 +15390,7 @@
                 <a:ea typeface="Microsoft YaHei" pitchFamily="34" charset="-122"/>
                 <a:cs typeface="Microsoft YaHei" pitchFamily="34" charset="-120"/>
               </a:rPr>
-              <a:t>• proof-bundle.json</a:t>
+              <a:t>• github-pr.md / checks</a:t>
             </a:r>
             <a:endParaRPr lang="en-US" sz="1150" dirty="0"/>
           </a:p>
@@ -15680,7 +15872,7 @@
                 <a:ea typeface="Microsoft YaHei" pitchFamily="34" charset="-122"/>
                 <a:cs typeface="Microsoft YaHei" pitchFamily="34" charset="-120"/>
               </a:rPr>
-              <a:t>agentteams/chronosfix.team.yaml 定义 4 个角色与职责边界</a:t>
+              <a:t>agentteams/chronosfix-team.yaml 定义 Manager、Human 与 7 个 Worker</a:t>
             </a:r>
             <a:endParaRPr lang="en-US" sz="950" dirty="0"/>
           </a:p>
@@ -15814,7 +16006,7 @@
                 <a:ea typeface="Microsoft YaHei" pitchFamily="34" charset="-122"/>
                 <a:cs typeface="Microsoft YaHei" pitchFamily="34" charset="-120"/>
               </a:rPr>
-              <a:t>事故建模 → 因果实验 → 候选补丁 → 风险门禁 → 证据护照</a:t>
+              <a:t>事故证据 → 反事实根因 → 缺陷基因 → RiskGate → PR 证据护照</a:t>
             </a:r>
             <a:endParaRPr lang="en-US" sz="950" dirty="0"/>
           </a:p>
@@ -17718,7 +17910,7 @@
                 <a:ea typeface="Microsoft YaHei" pitchFamily="34" charset="-122"/>
                 <a:cs typeface="Microsoft YaHei" pitchFamily="34" charset="-120"/>
               </a:rPr>
-              <a:t>• incident_id: INC-2026-08-11</a:t>
+              <a:t>• incident_id: INC-2026-0816-001</a:t>
             </a:r>
             <a:endParaRPr lang="en-US" sz="1050" dirty="0"/>
           </a:p>
@@ -17735,7 +17927,7 @@
                 <a:ea typeface="Microsoft YaHei" pitchFamily="34" charset="-122"/>
                 <a:cs typeface="Microsoft YaHei" pitchFamily="34" charset="-120"/>
               </a:rPr>
-              <a:t>• symptom: refund status stuck at PROCESSING</a:t>
+              <a:t>• symptom: checkout 5xx + P99 latency spike</a:t>
             </a:r>
             <a:endParaRPr lang="en-US" sz="1050" dirty="0"/>
           </a:p>
@@ -17752,7 +17944,7 @@
                 <a:ea typeface="Microsoft YaHei" pitchFamily="34" charset="-122"/>
                 <a:cs typeface="Microsoft YaHei" pitchFamily="34" charset="-120"/>
               </a:rPr>
-              <a:t>• suspect_change: payment-callback timeout policy</a:t>
+              <a:t>• suspect_change: db.pool.maxSize 24 → 8</a:t>
             </a:r>
             <a:endParaRPr lang="en-US" sz="1050" dirty="0"/>
           </a:p>
@@ -17903,7 +18095,7 @@
                 <a:ea typeface="Microsoft YaHei" pitchFamily="34" charset="-122"/>
                 <a:cs typeface="Microsoft YaHei" pitchFamily="34" charset="-120"/>
               </a:rPr>
-              <a:t>• root_cause: timeout unit mismatch</a:t>
+              <a:t>• root_cause: connection pool capacity shortage</a:t>
             </a:r>
             <a:endParaRPr lang="en-US" sz="1050" dirty="0"/>
           </a:p>
@@ -17920,7 +18112,7 @@
                 <a:ea typeface="Microsoft YaHei" pitchFamily="34" charset="-122"/>
                 <a:cs typeface="Microsoft YaHei" pitchFamily="34" charset="-120"/>
               </a:rPr>
-              <a:t>• patch: normalize callback timeout and idempotency check</a:t>
+              <a:t>• patch: restore pool 24 + capacity gate</a:t>
             </a:r>
             <a:endParaRPr lang="en-US" sz="1050" dirty="0"/>
           </a:p>
@@ -17954,7 +18146,7 @@
                 <a:ea typeface="Microsoft YaHei" pitchFamily="34" charset="-122"/>
                 <a:cs typeface="Microsoft YaHei" pitchFamily="34" charset="-120"/>
               </a:rPr>
-              <a:t>• evidence: proof-report, proof-bundle, trace, metrics, run-log</a:t>
+              <a:t>• evidence: proof-report, proof-bundle, GitHub PR, trace, metrics</a:t>
             </a:r>
             <a:endParaRPr lang="en-US" sz="1050" dirty="0"/>
           </a:p>

</xml_diff>

<commit_message>
Finalize semifinal submission audit and evidence boundaries
</commit_message>
<xml_diff>
--- a/submission/ChronosFix_复赛方案.pptx
+++ b/submission/ChronosFix_复赛方案.pptx
@@ -2,34 +2,34 @@
 <file path=ppt/presentation.xml><?xml version="1.0" encoding="utf-8"?>
 <p:presentation xmlns:p="http://schemas.openxmlformats.org/presentationml/2006/main">
   <p:sldMasterIdLst>
-    <p:sldMasterId xmlns:r="http://schemas.openxmlformats.org/officeDocument/2006/relationships" id="2147483648" r:id="R5a99157d50ac4df8"/>
+    <p:sldMasterId xmlns:r="http://schemas.openxmlformats.org/officeDocument/2006/relationships" id="2147483648" r:id="R55ad53815e4e443b"/>
   </p:sldMasterIdLst>
   <p:notesMasterIdLst>
-    <p:notesMasterId xmlns:r="http://schemas.openxmlformats.org/officeDocument/2006/relationships" r:id="Ra153814ba8b54a4f"/>
+    <p:notesMasterId xmlns:r="http://schemas.openxmlformats.org/officeDocument/2006/relationships" r:id="R312cb59c3e1a4cdc"/>
   </p:notesMasterIdLst>
   <p:sldIdLst>
-    <p:sldId xmlns:r="http://schemas.openxmlformats.org/officeDocument/2006/relationships" id="256" r:id="R9bbabb410dac4648"/>
-    <p:sldId xmlns:r="http://schemas.openxmlformats.org/officeDocument/2006/relationships" id="257" r:id="Rbaa63b587c2b4bcd"/>
-    <p:sldId xmlns:r="http://schemas.openxmlformats.org/officeDocument/2006/relationships" id="258" r:id="Rf38f3c20f9c24733"/>
-    <p:sldId xmlns:r="http://schemas.openxmlformats.org/officeDocument/2006/relationships" id="259" r:id="R9a94d0416f8a49a6"/>
-    <p:sldId xmlns:r="http://schemas.openxmlformats.org/officeDocument/2006/relationships" id="260" r:id="R544cbe8538b74d6d"/>
-    <p:sldId xmlns:r="http://schemas.openxmlformats.org/officeDocument/2006/relationships" id="261" r:id="Rbf9c915926174b62"/>
-    <p:sldId xmlns:r="http://schemas.openxmlformats.org/officeDocument/2006/relationships" id="262" r:id="Rb5f0abc2707b4e7e"/>
-    <p:sldId xmlns:r="http://schemas.openxmlformats.org/officeDocument/2006/relationships" id="263" r:id="R706f16e920d84be6"/>
-    <p:sldId xmlns:r="http://schemas.openxmlformats.org/officeDocument/2006/relationships" id="264" r:id="R57641c05da134113"/>
-    <p:sldId xmlns:r="http://schemas.openxmlformats.org/officeDocument/2006/relationships" id="265" r:id="R1eb842a309fe4c28"/>
-    <p:sldId xmlns:r="http://schemas.openxmlformats.org/officeDocument/2006/relationships" id="266" r:id="Rf343b0377a6c41ac"/>
-    <p:sldId xmlns:r="http://schemas.openxmlformats.org/officeDocument/2006/relationships" id="267" r:id="R4d27ac04a4e54379"/>
-    <p:sldId xmlns:r="http://schemas.openxmlformats.org/officeDocument/2006/relationships" id="268" r:id="R73b64b8c7b5b4d13"/>
-    <p:sldId xmlns:r="http://schemas.openxmlformats.org/officeDocument/2006/relationships" id="269" r:id="R65904888fa414a8e"/>
-    <p:sldId xmlns:r="http://schemas.openxmlformats.org/officeDocument/2006/relationships" id="270" r:id="R8028eec12af04866"/>
-    <p:sldId xmlns:r="http://schemas.openxmlformats.org/officeDocument/2006/relationships" id="271" r:id="Rfa4490761c644e67"/>
-    <p:sldId xmlns:r="http://schemas.openxmlformats.org/officeDocument/2006/relationships" id="272" r:id="R27b89d0c1d334fac"/>
-    <p:sldId xmlns:r="http://schemas.openxmlformats.org/officeDocument/2006/relationships" id="273" r:id="Rfa9ea04e6f5842da"/>
-    <p:sldId xmlns:r="http://schemas.openxmlformats.org/officeDocument/2006/relationships" id="274" r:id="R865b413e2f554222"/>
-    <p:sldId xmlns:r="http://schemas.openxmlformats.org/officeDocument/2006/relationships" id="275" r:id="R16a64041facd4810"/>
-    <p:sldId xmlns:r="http://schemas.openxmlformats.org/officeDocument/2006/relationships" id="276" r:id="R2961d7168b1341c8"/>
-    <p:sldId xmlns:r="http://schemas.openxmlformats.org/officeDocument/2006/relationships" id="277" r:id="R032ec40980d54ac7"/>
+    <p:sldId xmlns:r="http://schemas.openxmlformats.org/officeDocument/2006/relationships" id="256" r:id="Rdd7fcd7488f04236"/>
+    <p:sldId xmlns:r="http://schemas.openxmlformats.org/officeDocument/2006/relationships" id="257" r:id="Rb3ae95538b38426b"/>
+    <p:sldId xmlns:r="http://schemas.openxmlformats.org/officeDocument/2006/relationships" id="258" r:id="Rf2fb7c2a70c54d60"/>
+    <p:sldId xmlns:r="http://schemas.openxmlformats.org/officeDocument/2006/relationships" id="259" r:id="R23545eb3032144c1"/>
+    <p:sldId xmlns:r="http://schemas.openxmlformats.org/officeDocument/2006/relationships" id="260" r:id="Rd56d3eabcda14f12"/>
+    <p:sldId xmlns:r="http://schemas.openxmlformats.org/officeDocument/2006/relationships" id="261" r:id="R525a8527fd924a6f"/>
+    <p:sldId xmlns:r="http://schemas.openxmlformats.org/officeDocument/2006/relationships" id="262" r:id="R71605a7ed41b45ad"/>
+    <p:sldId xmlns:r="http://schemas.openxmlformats.org/officeDocument/2006/relationships" id="263" r:id="R6e1bd503aa1f43ef"/>
+    <p:sldId xmlns:r="http://schemas.openxmlformats.org/officeDocument/2006/relationships" id="264" r:id="R16004f46d3a04ab6"/>
+    <p:sldId xmlns:r="http://schemas.openxmlformats.org/officeDocument/2006/relationships" id="265" r:id="R0795dd9213aa486d"/>
+    <p:sldId xmlns:r="http://schemas.openxmlformats.org/officeDocument/2006/relationships" id="266" r:id="R01ebb32da2074493"/>
+    <p:sldId xmlns:r="http://schemas.openxmlformats.org/officeDocument/2006/relationships" id="267" r:id="R5a7424f82e204992"/>
+    <p:sldId xmlns:r="http://schemas.openxmlformats.org/officeDocument/2006/relationships" id="268" r:id="R1bf145b4749b41db"/>
+    <p:sldId xmlns:r="http://schemas.openxmlformats.org/officeDocument/2006/relationships" id="269" r:id="Rcb3e10ae90a44f4e"/>
+    <p:sldId xmlns:r="http://schemas.openxmlformats.org/officeDocument/2006/relationships" id="270" r:id="Rf56f53652dd24551"/>
+    <p:sldId xmlns:r="http://schemas.openxmlformats.org/officeDocument/2006/relationships" id="271" r:id="Rb00e406e75564d5f"/>
+    <p:sldId xmlns:r="http://schemas.openxmlformats.org/officeDocument/2006/relationships" id="272" r:id="R2726b0cdbdb74c40"/>
+    <p:sldId xmlns:r="http://schemas.openxmlformats.org/officeDocument/2006/relationships" id="273" r:id="R700fcfdf84804b77"/>
+    <p:sldId xmlns:r="http://schemas.openxmlformats.org/officeDocument/2006/relationships" id="274" r:id="Rd5d5dc1ee25b4706"/>
+    <p:sldId xmlns:r="http://schemas.openxmlformats.org/officeDocument/2006/relationships" id="275" r:id="Re0f7375bd2bf49a8"/>
+    <p:sldId xmlns:r="http://schemas.openxmlformats.org/officeDocument/2006/relationships" id="276" r:id="R63f41356b6c24df9"/>
+    <p:sldId xmlns:r="http://schemas.openxmlformats.org/officeDocument/2006/relationships" id="277" r:id="R9d42c475625943e9"/>
   </p:sldIdLst>
   <p:sldSz cx="12192000" cy="6858000"/>
   <p:notesSz cx="6858000" cy="9144000"/>
@@ -2381,7 +2381,7 @@
   </p:cSld>
   <p:clrMap bg1="lt1" tx1="dk1" bg2="lt2" tx2="dk2" accent1="accent1" accent2="accent2" accent3="accent3" accent4="accent4" accent5="accent5" accent6="accent6" hlink="hlink" folHlink="folHlink"/>
   <p:sldLayoutIdLst>
-    <p:sldLayoutId xmlns:r="http://schemas.openxmlformats.org/officeDocument/2006/relationships" id="2147483649" r:id="R540d799d6ece4b9d"/>
+    <p:sldLayoutId xmlns:r="http://schemas.openxmlformats.org/officeDocument/2006/relationships" id="2147483649" r:id="R62a156f7bfda4d95"/>
   </p:sldLayoutIdLst>
   <p:txStyles>
     <p:titleStyle>
@@ -3106,7 +3106,7 @@
                   <a:srgbClr val="FFFFFF"/>
                 </a:solidFill>
               </a:rPr>
-              <a:t>A-CFX：带证据的软件修复引擎</a:t>
+              <a:t>A-CFX：带证明的软件变更基础设施</a:t>
             </a:r>
           </a:p>
         </p:txBody>
@@ -15896,7 +15896,7 @@
                   <a:srgbClr val="101828"/>
                 </a:solidFill>
               </a:rPr>
-              <a:t>AsoulAI ChronosFix（A-CFX）</a:t>
+              <a:t>ChronosFix（A-CFX）</a:t>
             </a:r>
           </a:p>
           <a:p xmlns:a="http://schemas.openxmlformats.org/drawingml/2006/main">
@@ -15914,7 +15914,7 @@
                   <a:srgbClr val="101828"/>
                 </a:solidFill>
               </a:rPr>
-              <a:t>带证据的软件修复引擎</a:t>
+              <a:t>带证明的软件变更基础设施</a:t>
             </a:r>
           </a:p>
         </p:txBody>
@@ -19223,7 +19223,7 @@
                   <a:srgbClr val="101828"/>
                 </a:solidFill>
               </a:rPr>
-              <a:t>AsoulAI ChronosFix：带证据的软件修复引擎</a:t>
+              <a:t>ChronosFix：带证明的软件变更基础设施</a:t>
             </a:r>
           </a:p>
         </p:txBody>

</xml_diff>

<commit_message>
Prepare semifinal dynamic coordination submission
</commit_message>
<xml_diff>
--- a/submission/ChronosFix_复赛方案.pptx
+++ b/submission/ChronosFix_复赛方案.pptx
@@ -2,34 +2,34 @@
 <file path=ppt/presentation.xml><?xml version="1.0" encoding="utf-8"?>
 <p:presentation xmlns:p="http://schemas.openxmlformats.org/presentationml/2006/main">
   <p:sldMasterIdLst>
-    <p:sldMasterId xmlns:r="http://schemas.openxmlformats.org/officeDocument/2006/relationships" id="2147483648" r:id="R55ad53815e4e443b"/>
+    <p:sldMasterId xmlns:r="http://schemas.openxmlformats.org/officeDocument/2006/relationships" id="2147483648" r:id="R82d3338c37eb4150"/>
   </p:sldMasterIdLst>
   <p:notesMasterIdLst>
-    <p:notesMasterId xmlns:r="http://schemas.openxmlformats.org/officeDocument/2006/relationships" r:id="R312cb59c3e1a4cdc"/>
+    <p:notesMasterId xmlns:r="http://schemas.openxmlformats.org/officeDocument/2006/relationships" r:id="R46b9e13645304143"/>
   </p:notesMasterIdLst>
   <p:sldIdLst>
-    <p:sldId xmlns:r="http://schemas.openxmlformats.org/officeDocument/2006/relationships" id="256" r:id="Rdd7fcd7488f04236"/>
-    <p:sldId xmlns:r="http://schemas.openxmlformats.org/officeDocument/2006/relationships" id="257" r:id="Rb3ae95538b38426b"/>
-    <p:sldId xmlns:r="http://schemas.openxmlformats.org/officeDocument/2006/relationships" id="258" r:id="Rf2fb7c2a70c54d60"/>
-    <p:sldId xmlns:r="http://schemas.openxmlformats.org/officeDocument/2006/relationships" id="259" r:id="R23545eb3032144c1"/>
-    <p:sldId xmlns:r="http://schemas.openxmlformats.org/officeDocument/2006/relationships" id="260" r:id="Rd56d3eabcda14f12"/>
-    <p:sldId xmlns:r="http://schemas.openxmlformats.org/officeDocument/2006/relationships" id="261" r:id="R525a8527fd924a6f"/>
-    <p:sldId xmlns:r="http://schemas.openxmlformats.org/officeDocument/2006/relationships" id="262" r:id="R71605a7ed41b45ad"/>
-    <p:sldId xmlns:r="http://schemas.openxmlformats.org/officeDocument/2006/relationships" id="263" r:id="R6e1bd503aa1f43ef"/>
-    <p:sldId xmlns:r="http://schemas.openxmlformats.org/officeDocument/2006/relationships" id="264" r:id="R16004f46d3a04ab6"/>
-    <p:sldId xmlns:r="http://schemas.openxmlformats.org/officeDocument/2006/relationships" id="265" r:id="R0795dd9213aa486d"/>
-    <p:sldId xmlns:r="http://schemas.openxmlformats.org/officeDocument/2006/relationships" id="266" r:id="R01ebb32da2074493"/>
-    <p:sldId xmlns:r="http://schemas.openxmlformats.org/officeDocument/2006/relationships" id="267" r:id="R5a7424f82e204992"/>
-    <p:sldId xmlns:r="http://schemas.openxmlformats.org/officeDocument/2006/relationships" id="268" r:id="R1bf145b4749b41db"/>
-    <p:sldId xmlns:r="http://schemas.openxmlformats.org/officeDocument/2006/relationships" id="269" r:id="Rcb3e10ae90a44f4e"/>
-    <p:sldId xmlns:r="http://schemas.openxmlformats.org/officeDocument/2006/relationships" id="270" r:id="Rf56f53652dd24551"/>
-    <p:sldId xmlns:r="http://schemas.openxmlformats.org/officeDocument/2006/relationships" id="271" r:id="Rb00e406e75564d5f"/>
-    <p:sldId xmlns:r="http://schemas.openxmlformats.org/officeDocument/2006/relationships" id="272" r:id="R2726b0cdbdb74c40"/>
-    <p:sldId xmlns:r="http://schemas.openxmlformats.org/officeDocument/2006/relationships" id="273" r:id="R700fcfdf84804b77"/>
-    <p:sldId xmlns:r="http://schemas.openxmlformats.org/officeDocument/2006/relationships" id="274" r:id="Rd5d5dc1ee25b4706"/>
-    <p:sldId xmlns:r="http://schemas.openxmlformats.org/officeDocument/2006/relationships" id="275" r:id="Re0f7375bd2bf49a8"/>
-    <p:sldId xmlns:r="http://schemas.openxmlformats.org/officeDocument/2006/relationships" id="276" r:id="R63f41356b6c24df9"/>
-    <p:sldId xmlns:r="http://schemas.openxmlformats.org/officeDocument/2006/relationships" id="277" r:id="R9d42c475625943e9"/>
+    <p:sldId xmlns:r="http://schemas.openxmlformats.org/officeDocument/2006/relationships" id="256" r:id="R8cdf56d527fc48d1"/>
+    <p:sldId xmlns:r="http://schemas.openxmlformats.org/officeDocument/2006/relationships" id="257" r:id="Ra41803ce7cd04ecd"/>
+    <p:sldId xmlns:r="http://schemas.openxmlformats.org/officeDocument/2006/relationships" id="258" r:id="Rae62b7344c5d4fe3"/>
+    <p:sldId xmlns:r="http://schemas.openxmlformats.org/officeDocument/2006/relationships" id="259" r:id="R30be5c84c6b2473a"/>
+    <p:sldId xmlns:r="http://schemas.openxmlformats.org/officeDocument/2006/relationships" id="260" r:id="R54bf9a75c7f745cd"/>
+    <p:sldId xmlns:r="http://schemas.openxmlformats.org/officeDocument/2006/relationships" id="261" r:id="R2463c95759d44a1e"/>
+    <p:sldId xmlns:r="http://schemas.openxmlformats.org/officeDocument/2006/relationships" id="262" r:id="Rf9aa7c9f340f4cdc"/>
+    <p:sldId xmlns:r="http://schemas.openxmlformats.org/officeDocument/2006/relationships" id="263" r:id="R2783e86c11ea487b"/>
+    <p:sldId xmlns:r="http://schemas.openxmlformats.org/officeDocument/2006/relationships" id="264" r:id="Re9627e8670d34dc2"/>
+    <p:sldId xmlns:r="http://schemas.openxmlformats.org/officeDocument/2006/relationships" id="265" r:id="R20b51addd8714b35"/>
+    <p:sldId xmlns:r="http://schemas.openxmlformats.org/officeDocument/2006/relationships" id="266" r:id="R306187d6d53b41e6"/>
+    <p:sldId xmlns:r="http://schemas.openxmlformats.org/officeDocument/2006/relationships" id="267" r:id="R8405997e52444923"/>
+    <p:sldId xmlns:r="http://schemas.openxmlformats.org/officeDocument/2006/relationships" id="268" r:id="R25f10e8105df4cbd"/>
+    <p:sldId xmlns:r="http://schemas.openxmlformats.org/officeDocument/2006/relationships" id="269" r:id="R7d339ad7b69b4bbe"/>
+    <p:sldId xmlns:r="http://schemas.openxmlformats.org/officeDocument/2006/relationships" id="270" r:id="Rc54b56063f054ef5"/>
+    <p:sldId xmlns:r="http://schemas.openxmlformats.org/officeDocument/2006/relationships" id="271" r:id="R3814d050d02a4301"/>
+    <p:sldId xmlns:r="http://schemas.openxmlformats.org/officeDocument/2006/relationships" id="272" r:id="Rec975531d43f4520"/>
+    <p:sldId xmlns:r="http://schemas.openxmlformats.org/officeDocument/2006/relationships" id="273" r:id="Rc85410e83a214c11"/>
+    <p:sldId xmlns:r="http://schemas.openxmlformats.org/officeDocument/2006/relationships" id="274" r:id="Ree9dec0d65ca4bed"/>
+    <p:sldId xmlns:r="http://schemas.openxmlformats.org/officeDocument/2006/relationships" id="275" r:id="R875b6ccefef14de3"/>
+    <p:sldId xmlns:r="http://schemas.openxmlformats.org/officeDocument/2006/relationships" id="276" r:id="Rd8570f57a7394557"/>
+    <p:sldId xmlns:r="http://schemas.openxmlformats.org/officeDocument/2006/relationships" id="277" r:id="Rac2fb7e7f0db4274"/>
   </p:sldIdLst>
   <p:sldSz cx="12192000" cy="6858000"/>
   <p:notesSz cx="6858000" cy="9144000"/>
@@ -2381,7 +2381,7 @@
   </p:cSld>
   <p:clrMap bg1="lt1" tx1="dk1" bg2="lt2" tx2="dk2" accent1="accent1" accent2="accent2" accent3="accent3" accent4="accent4" accent5="accent5" accent6="accent6" hlink="hlink" folHlink="folHlink"/>
   <p:sldLayoutIdLst>
-    <p:sldLayoutId xmlns:r="http://schemas.openxmlformats.org/officeDocument/2006/relationships" id="2147483649" r:id="R62a156f7bfda4d95"/>
+    <p:sldLayoutId xmlns:r="http://schemas.openxmlformats.org/officeDocument/2006/relationships" id="2147483649" r:id="R29f68fb81e5b42b6"/>
   </p:sldLayoutIdLst>
   <p:txStyles>
     <p:titleStyle>
@@ -3106,7 +3106,7 @@
                   <a:srgbClr val="FFFFFF"/>
                 </a:solidFill>
               </a:rPr>
-              <a:t>A-CFX：带证明的软件变更基础设施</a:t>
+              <a:t>A-CFX：软件故障时间机器</a:t>
             </a:r>
           </a:p>
         </p:txBody>
@@ -3157,7 +3157,7 @@
                   <a:srgbClr val="D7E3F5"/>
                 </a:solidFill>
               </a:rPr>
-              <a:t>用多 Agent 把事故变成可验证补丁与可复用质量资产</a:t>
+              <a:t>让每次变更都携带可验证证据</a:t>
             </a:r>
           </a:p>
         </p:txBody>
@@ -5571,7 +5571,7 @@
                   <a:srgbClr val="101828"/>
                 </a:solidFill>
               </a:rPr>
-              <a:t>10 个 Skill 能力覆盖证据、因果、验证与资产复用</a:t>
+              <a:t>10 个 Skill 能力覆盖证据、因果、验证、协同与资产复用</a:t>
             </a:r>
           </a:p>
         </p:txBody>
@@ -5622,7 +5622,7 @@
                   <a:srgbClr val="64748B"/>
                 </a:solidFill>
               </a:rPr>
-              <a:t>每项能力都有稳定契约、权限边界、验证方式和版本演进路径。</a:t>
+              <a:t>每项能力有契约、权限边界、运行时发现、验证方式和版本演进。</a:t>
             </a:r>
           </a:p>
         </p:txBody>
@@ -10421,7 +10421,7 @@
                   <a:srgbClr val="64748B"/>
                 </a:solidFill>
               </a:rPr>
-              <a:t>scenario、patch、rollback、approval 与 15 个输出文件由 run-manifest 哈希绑定。</a:t>
+              <a:t>scenario、patch、rollback、approval、coordination 与 16 个输出文件由 run-manifest 哈希绑定。</a:t>
             </a:r>
           </a:p>
         </p:txBody>
@@ -11053,7 +11053,7 @@
                   <a:srgbClr val="101828"/>
                 </a:solidFill>
               </a:rPr>
-              <a:t>Metrics 明确区分 measured / derived；外部工具未调用时 success_rate=null。</a:t>
+              <a:t>Metrics 区分 measured / derived；协调事件含 revision、attempt、dedup 和 pause/resume。</a:t>
             </a:r>
           </a:p>
         </p:txBody>
@@ -11221,7 +11221,7 @@
                   <a:srgbClr val="101828"/>
                 </a:solidFill>
               </a:rPr>
-              <a:t>当前主证据 run_id：run-1dc8539c…；trace_id：2c597183…；可在 evidence/ 复核。</a:t>
+              <a:t>当前主证据 run_id：run-a9200f31…；trace_id：df6e0a144…；coordination.json 可复核。</a:t>
             </a:r>
           </a:p>
         </p:txBody>
@@ -14949,7 +14949,7 @@
                   <a:srgbClr val="101828"/>
                 </a:solidFill>
               </a:rPr>
-              <a:t>agentteams/run_chronosfix_team.py 输出 compatible transcript 与同源证据。</a:t>
+              <a:t>agentteams/run_chronosfix_team.py 输出动态 transcript、任务事件与同源证据。</a:t>
             </a:r>
           </a:p>
         </p:txBody>
@@ -15086,7 +15086,7 @@
                   <a:srgbClr val="101828"/>
                 </a:solidFill>
               </a:rPr>
-              <a:t>scenario.schema.json + v1beta1 校验；Python 3.10–3.12 跑 36 项测试。</a:t>
+              <a:t>scenario.schema.json + v1beta1 校验；Python 3.10–3.12 跑 40 项测试。</a:t>
             </a:r>
           </a:p>
         </p:txBody>
@@ -15708,7 +15708,7 @@
                   <a:srgbClr val="101828"/>
                 </a:solidFill>
               </a:rPr>
-              <a:t>把“会修复”升级为“带证据、可发布、可复用”</a:t>
+              <a:t>把“会修复”升级为“可验证、可协同、可发布”</a:t>
             </a:r>
           </a:p>
         </p:txBody>
@@ -15759,7 +15759,7 @@
                   <a:srgbClr val="64748B"/>
                 </a:solidFill>
               </a:rPr>
-              <a:t>复赛版补齐 AgentTeams、云 Skill、评测、失败处理、权限与开源规范。</a:t>
+              <a:t>复赛版补齐动态协同、可发现 Skill、异常注入、评测、权限与开源规范。</a:t>
             </a:r>
           </a:p>
         </p:txBody>
@@ -16188,7 +16188,7 @@
                   <a:srgbClr val="101828"/>
                 </a:solidFill>
               </a:rPr>
-              <a:t>8 个职能 Worker 协同重放事故；10 个 Skill 能力完成因果、验证、门禁与资产沉淀。</a:t>
+              <a:t>DynamicScheduler 驱动 8 个 Worker；证据触发任务插入、失败重派与人工恢复。</a:t>
             </a:r>
           </a:p>
         </p:txBody>
@@ -16325,7 +16325,7 @@
                   <a:srgbClr val="101828"/>
                 </a:solidFill>
               </a:rPr>
-              <a:t>Proof-Carrying Change + 可辨识性仲裁：无法区分就拒答，证据不全就阻断发布。</a:t>
+              <a:t>Proof-Carrying Change + 动态协同：无法区分就拒答，证据不全就阻断发布。</a:t>
             </a:r>
           </a:p>
         </p:txBody>
@@ -16599,7 +16599,7 @@
                   <a:srgbClr val="101828"/>
                 </a:solidFill>
               </a:rPr>
-              <a:t>36 项测试；9/9 支持范围诊断正确；1/1 冲突安全拒答；2 项边界透明保留。</a:t>
+              <a:t>40 项测试；9/9 支持范围诊断正确；1/1 冲突安全拒答；动态协同有运行证据。</a:t>
             </a:r>
           </a:p>
         </p:txBody>
@@ -18581,7 +18581,7 @@
                   <a:srgbClr val="101828"/>
                 </a:solidFill>
               </a:rPr>
-              <a:t>当前状态：Controller / Matrix 尚未执行；真实 SLS 需要本地只读凭证；其余推荐组件为迁移目标。</a:t>
+              <a:t>当前状态：本地动态控制面已实测；Controller / Matrix、真实 SLS 与 canary 仍待外部环境。</a:t>
             </a:r>
           </a:p>
         </p:txBody>
@@ -19223,7 +19223,7 @@
                   <a:srgbClr val="101828"/>
                 </a:solidFill>
               </a:rPr>
-              <a:t>ChronosFix：带证明的软件变更基础设施</a:t>
+              <a:t>ChronosFix：软件故障时间机器</a:t>
             </a:r>
           </a:p>
         </p:txBody>
@@ -19909,7 +19909,7 @@
                   <a:srgbClr val="101828"/>
                 </a:solidFill>
               </a:rPr>
-              <a:t>根因可证明｜补丁可验证｜发布可审计｜经验可复用</a:t>
+              <a:t>根因可证明｜补丁可验证｜发布可审计｜事故可复用</a:t>
             </a:r>
           </a:p>
         </p:txBody>
@@ -19960,7 +19960,7 @@
                   <a:srgbClr val="101828"/>
                 </a:solidFill>
               </a:rPr>
-              <a:t>A-CFX：让每次软件修复都携带证据，让每次事故都沉淀为质量资产。</a:t>
+              <a:t>A-CFX：让每次软件变更都携带证据，让每次事故都沉淀为质量资产。</a:t>
             </a:r>
           </a:p>
         </p:txBody>
@@ -22589,7 +22589,7 @@
                   <a:srgbClr val="16A34A"/>
                 </a:solidFill>
               </a:rPr>
-              <a:t>36</a:t>
+              <a:t>40</a:t>
             </a:r>
           </a:p>
         </p:txBody>
@@ -24907,7 +24907,7 @@
                   <a:srgbClr val="101828"/>
                 </a:solidFill>
               </a:rPr>
-              <a:t>18 个实测 Span、3 个必须 checks、15 个主输出文件；全部关联同一 run_id。</a:t>
+              <a:t>18 个 Span、6 个动态任务、38 个协同事件；均关联同一 run_id。</a:t>
             </a:r>
           </a:p>
         </p:txBody>
@@ -25711,7 +25711,7 @@
                   <a:srgbClr val="101828"/>
                 </a:solidFill>
               </a:rPr>
-              <a:t>AgentTeams v1beta1：正式资源已离线校验</a:t>
+              <a:t>AgentTeams v1beta1：资源声明与动态任务图</a:t>
             </a:r>
           </a:p>
         </p:txBody>
@@ -27680,7 +27680,7 @@
                   <a:srgbClr val="101828"/>
                 </a:solidFill>
               </a:rPr>
-              <a:t>角色靠状态契约协同，而不是在聊天室投票</a:t>
+              <a:t>角色靠状态契约协同，任务会随证据变化</a:t>
             </a:r>
           </a:p>
         </p:txBody>
@@ -27731,7 +27731,7 @@
                   <a:srgbClr val="64748B"/>
                 </a:solidFill>
               </a:rPr>
-              <a:t>每个 Worker 只写负责的状态分区；Commander 只做路由、裁决与升级。</a:t>
+              <a:t>Worker 只写负责分区；Commander 做路由、裁决与升级；新证据可插入任务。</a:t>
             </a:r>
           </a:p>
         </p:txBody>
@@ -29139,8 +29139,8 @@
                   <a:srgbClr val="101828"/>
                 </a:solidFill>
               </a:rPr>
-              <a:t>IncidentState + Schema
-实验 / 补丁 / 审批</a:t>
+              <a:t>IncidentState + revision
+任务图 / 实验 / 补丁 / 审批</a:t>
             </a:r>
           </a:p>
         </p:txBody>
@@ -29277,8 +29277,8 @@
                   <a:srgbClr val="101828"/>
                 </a:solidFill>
               </a:rPr>
-              <a:t>run / trace / parent
-Agent / check / PR</a:t>
+              <a:t>run / trace / state revision
+attempt / reassign / PR</a:t>
             </a:r>
           </a:p>
         </p:txBody>
@@ -29415,8 +29415,8 @@
                   <a:srgbClr val="101828"/>
                 </a:solidFill>
               </a:rPr>
-              <a:t>missing / indeterminate
-高风险→Human</a:t>
+              <a:t>timeout→reassign / duplicate→dedup
+stale approval→pause</a:t>
             </a:r>
           </a:p>
         </p:txBody>

</xml_diff>

<commit_message>
Add finals-grade failure injection and release integrity
</commit_message>
<xml_diff>
--- a/submission/ChronosFix_复赛方案.pptx
+++ b/submission/ChronosFix_复赛方案.pptx
@@ -2,34 +2,34 @@
 <file path=ppt/presentation.xml><?xml version="1.0" encoding="utf-8"?>
 <p:presentation xmlns:p="http://schemas.openxmlformats.org/presentationml/2006/main">
   <p:sldMasterIdLst>
-    <p:sldMasterId xmlns:r="http://schemas.openxmlformats.org/officeDocument/2006/relationships" id="2147483648" r:id="R82d3338c37eb4150"/>
+    <p:sldMasterId xmlns:r="http://schemas.openxmlformats.org/officeDocument/2006/relationships" id="2147483648" r:id="R07ecdc7f5d6948ca"/>
   </p:sldMasterIdLst>
   <p:notesMasterIdLst>
-    <p:notesMasterId xmlns:r="http://schemas.openxmlformats.org/officeDocument/2006/relationships" r:id="R46b9e13645304143"/>
+    <p:notesMasterId xmlns:r="http://schemas.openxmlformats.org/officeDocument/2006/relationships" r:id="R1301e7282bc64122"/>
   </p:notesMasterIdLst>
   <p:sldIdLst>
-    <p:sldId xmlns:r="http://schemas.openxmlformats.org/officeDocument/2006/relationships" id="256" r:id="R8cdf56d527fc48d1"/>
-    <p:sldId xmlns:r="http://schemas.openxmlformats.org/officeDocument/2006/relationships" id="257" r:id="Ra41803ce7cd04ecd"/>
-    <p:sldId xmlns:r="http://schemas.openxmlformats.org/officeDocument/2006/relationships" id="258" r:id="Rae62b7344c5d4fe3"/>
-    <p:sldId xmlns:r="http://schemas.openxmlformats.org/officeDocument/2006/relationships" id="259" r:id="R30be5c84c6b2473a"/>
-    <p:sldId xmlns:r="http://schemas.openxmlformats.org/officeDocument/2006/relationships" id="260" r:id="R54bf9a75c7f745cd"/>
-    <p:sldId xmlns:r="http://schemas.openxmlformats.org/officeDocument/2006/relationships" id="261" r:id="R2463c95759d44a1e"/>
-    <p:sldId xmlns:r="http://schemas.openxmlformats.org/officeDocument/2006/relationships" id="262" r:id="Rf9aa7c9f340f4cdc"/>
-    <p:sldId xmlns:r="http://schemas.openxmlformats.org/officeDocument/2006/relationships" id="263" r:id="R2783e86c11ea487b"/>
-    <p:sldId xmlns:r="http://schemas.openxmlformats.org/officeDocument/2006/relationships" id="264" r:id="Re9627e8670d34dc2"/>
-    <p:sldId xmlns:r="http://schemas.openxmlformats.org/officeDocument/2006/relationships" id="265" r:id="R20b51addd8714b35"/>
-    <p:sldId xmlns:r="http://schemas.openxmlformats.org/officeDocument/2006/relationships" id="266" r:id="R306187d6d53b41e6"/>
-    <p:sldId xmlns:r="http://schemas.openxmlformats.org/officeDocument/2006/relationships" id="267" r:id="R8405997e52444923"/>
-    <p:sldId xmlns:r="http://schemas.openxmlformats.org/officeDocument/2006/relationships" id="268" r:id="R25f10e8105df4cbd"/>
-    <p:sldId xmlns:r="http://schemas.openxmlformats.org/officeDocument/2006/relationships" id="269" r:id="R7d339ad7b69b4bbe"/>
-    <p:sldId xmlns:r="http://schemas.openxmlformats.org/officeDocument/2006/relationships" id="270" r:id="Rc54b56063f054ef5"/>
-    <p:sldId xmlns:r="http://schemas.openxmlformats.org/officeDocument/2006/relationships" id="271" r:id="R3814d050d02a4301"/>
-    <p:sldId xmlns:r="http://schemas.openxmlformats.org/officeDocument/2006/relationships" id="272" r:id="Rec975531d43f4520"/>
-    <p:sldId xmlns:r="http://schemas.openxmlformats.org/officeDocument/2006/relationships" id="273" r:id="Rc85410e83a214c11"/>
-    <p:sldId xmlns:r="http://schemas.openxmlformats.org/officeDocument/2006/relationships" id="274" r:id="Ree9dec0d65ca4bed"/>
-    <p:sldId xmlns:r="http://schemas.openxmlformats.org/officeDocument/2006/relationships" id="275" r:id="R875b6ccefef14de3"/>
-    <p:sldId xmlns:r="http://schemas.openxmlformats.org/officeDocument/2006/relationships" id="276" r:id="Rd8570f57a7394557"/>
-    <p:sldId xmlns:r="http://schemas.openxmlformats.org/officeDocument/2006/relationships" id="277" r:id="Rac2fb7e7f0db4274"/>
+    <p:sldId xmlns:r="http://schemas.openxmlformats.org/officeDocument/2006/relationships" id="256" r:id="R8dc6d0b6aa3a404f"/>
+    <p:sldId xmlns:r="http://schemas.openxmlformats.org/officeDocument/2006/relationships" id="257" r:id="R01dbf4bc931c4fb1"/>
+    <p:sldId xmlns:r="http://schemas.openxmlformats.org/officeDocument/2006/relationships" id="258" r:id="Rf20ad245d9514dfc"/>
+    <p:sldId xmlns:r="http://schemas.openxmlformats.org/officeDocument/2006/relationships" id="259" r:id="R09085f90563547fd"/>
+    <p:sldId xmlns:r="http://schemas.openxmlformats.org/officeDocument/2006/relationships" id="260" r:id="R88af00e0c03140b7"/>
+    <p:sldId xmlns:r="http://schemas.openxmlformats.org/officeDocument/2006/relationships" id="261" r:id="R4f63ab2c8f94458d"/>
+    <p:sldId xmlns:r="http://schemas.openxmlformats.org/officeDocument/2006/relationships" id="262" r:id="R0c16223d39114f7b"/>
+    <p:sldId xmlns:r="http://schemas.openxmlformats.org/officeDocument/2006/relationships" id="263" r:id="R7cf74e30176c43c3"/>
+    <p:sldId xmlns:r="http://schemas.openxmlformats.org/officeDocument/2006/relationships" id="264" r:id="R9204c654174c4e29"/>
+    <p:sldId xmlns:r="http://schemas.openxmlformats.org/officeDocument/2006/relationships" id="265" r:id="R839390e6349b4b9d"/>
+    <p:sldId xmlns:r="http://schemas.openxmlformats.org/officeDocument/2006/relationships" id="266" r:id="Redfd631a7ca8418e"/>
+    <p:sldId xmlns:r="http://schemas.openxmlformats.org/officeDocument/2006/relationships" id="267" r:id="R99c074d72b84412a"/>
+    <p:sldId xmlns:r="http://schemas.openxmlformats.org/officeDocument/2006/relationships" id="268" r:id="R8f3e523575e7440a"/>
+    <p:sldId xmlns:r="http://schemas.openxmlformats.org/officeDocument/2006/relationships" id="269" r:id="R53fa5c3bad534cca"/>
+    <p:sldId xmlns:r="http://schemas.openxmlformats.org/officeDocument/2006/relationships" id="270" r:id="Raa90ce716b1f4ef5"/>
+    <p:sldId xmlns:r="http://schemas.openxmlformats.org/officeDocument/2006/relationships" id="271" r:id="R866def4966e442e6"/>
+    <p:sldId xmlns:r="http://schemas.openxmlformats.org/officeDocument/2006/relationships" id="272" r:id="Ra03035e3b11740e7"/>
+    <p:sldId xmlns:r="http://schemas.openxmlformats.org/officeDocument/2006/relationships" id="273" r:id="R062f277f50014cee"/>
+    <p:sldId xmlns:r="http://schemas.openxmlformats.org/officeDocument/2006/relationships" id="274" r:id="R3024174802cd4344"/>
+    <p:sldId xmlns:r="http://schemas.openxmlformats.org/officeDocument/2006/relationships" id="275" r:id="R5ef177b21cdc44dc"/>
+    <p:sldId xmlns:r="http://schemas.openxmlformats.org/officeDocument/2006/relationships" id="276" r:id="R583d4d1937c44360"/>
+    <p:sldId xmlns:r="http://schemas.openxmlformats.org/officeDocument/2006/relationships" id="277" r:id="R5f01bbf70b0f4e77"/>
   </p:sldIdLst>
   <p:sldSz cx="12192000" cy="6858000"/>
   <p:notesSz cx="6858000" cy="9144000"/>
@@ -2381,7 +2381,7 @@
   </p:cSld>
   <p:clrMap bg1="lt1" tx1="dk1" bg2="lt2" tx2="dk2" accent1="accent1" accent2="accent2" accent3="accent3" accent4="accent4" accent5="accent5" accent6="accent6" hlink="hlink" folHlink="folHlink"/>
   <p:sldLayoutIdLst>
-    <p:sldLayoutId xmlns:r="http://schemas.openxmlformats.org/officeDocument/2006/relationships" id="2147483649" r:id="R29f68fb81e5b42b6"/>
+    <p:sldLayoutId xmlns:r="http://schemas.openxmlformats.org/officeDocument/2006/relationships" id="2147483649" r:id="R214feafd5ca84d50"/>
   </p:sldLayoutIdLst>
   <p:txStyles>
     <p:titleStyle>
@@ -3106,7 +3106,7 @@
                   <a:srgbClr val="FFFFFF"/>
                 </a:solidFill>
               </a:rPr>
-              <a:t>A-CFX：软件故障时间机器</a:t>
+              <a:t>A-CFX：带证据的软件修复引擎</a:t>
             </a:r>
           </a:p>
         </p:txBody>
@@ -3157,7 +3157,7 @@
                   <a:srgbClr val="D7E3F5"/>
                 </a:solidFill>
               </a:rPr>
-              <a:t>让每次变更都携带可验证证据</a:t>
+              <a:t>用多 Agent 把事故变成可验证补丁与可复用质量资产</a:t>
             </a:r>
           </a:p>
         </p:txBody>
@@ -5571,7 +5571,7 @@
                   <a:srgbClr val="101828"/>
                 </a:solidFill>
               </a:rPr>
-              <a:t>10 个 Skill 能力覆盖证据、因果、验证、协同与资产复用</a:t>
+              <a:t>10 个 Skill 能力覆盖证据、因果、验证与资产复用</a:t>
             </a:r>
           </a:p>
         </p:txBody>
@@ -5622,7 +5622,7 @@
                   <a:srgbClr val="64748B"/>
                 </a:solidFill>
               </a:rPr>
-              <a:t>每项能力有契约、权限边界、运行时发现、验证方式和版本演进。</a:t>
+              <a:t>每项能力都有稳定契约、权限边界、验证方式和版本演进路径。</a:t>
             </a:r>
           </a:p>
         </p:txBody>
@@ -7638,8 +7638,7 @@
                   <a:srgbClr val="101828"/>
                 </a:solidFill>
               </a:rPr>
-              <a:t>只读 GetIndex / GetLogsV2
-窗口≤24h</a:t>
+              <a:t>18 个 Trace Span 覆盖 Agent/Skill 调用、实验结果、风险门禁和报告生成。</a:t>
             </a:r>
           </a:p>
         </p:txBody>
@@ -10421,7 +10420,7 @@
                   <a:srgbClr val="64748B"/>
                 </a:solidFill>
               </a:rPr>
-              <a:t>scenario、patch、rollback、approval、coordination 与 16 个输出文件由 run-manifest 哈希绑定。</a:t>
+              <a:t>scenario、patch、rollback、approval 与 15 个输出文件由 run-manifest 哈希绑定。</a:t>
             </a:r>
           </a:p>
         </p:txBody>
@@ -11053,7 +11052,7 @@
                   <a:srgbClr val="101828"/>
                 </a:solidFill>
               </a:rPr>
-              <a:t>Metrics 区分 measured / derived；协调事件含 revision、attempt、dedup 和 pause/resume。</a:t>
+              <a:t>Metrics 明确区分 measured / derived；外部工具未调用时 success_rate=null。</a:t>
             </a:r>
           </a:p>
         </p:txBody>
@@ -11221,7 +11220,7 @@
                   <a:srgbClr val="101828"/>
                 </a:solidFill>
               </a:rPr>
-              <a:t>当前主证据 run_id：run-a9200f31…；trace_id：df6e0a144…；coordination.json 可复核。</a:t>
+              <a:t>当前主证据 run_id：run-1dc8539c…；trace_id：2c597183…；可在 evidence/ 复核。</a:t>
             </a:r>
           </a:p>
         </p:txBody>
@@ -14949,7 +14948,7 @@
                   <a:srgbClr val="101828"/>
                 </a:solidFill>
               </a:rPr>
-              <a:t>agentteams/run_chronosfix_team.py 输出动态 transcript、任务事件与同源证据。</a:t>
+              <a:t>agentteams/run_chronosfix_team.py 输出 compatible transcript 与同源证据。</a:t>
             </a:r>
           </a:p>
         </p:txBody>
@@ -15086,7 +15085,7 @@
                   <a:srgbClr val="101828"/>
                 </a:solidFill>
               </a:rPr>
-              <a:t>scenario.schema.json + v1beta1 校验；Python 3.10–3.12 跑 40 项测试。</a:t>
+              <a:t>18 个 Trace Span 覆盖 Agent/Skill 调用、实验结果、风险门禁和报告生成。</a:t>
             </a:r>
           </a:p>
         </p:txBody>
@@ -15708,7 +15707,7 @@
                   <a:srgbClr val="101828"/>
                 </a:solidFill>
               </a:rPr>
-              <a:t>把“会修复”升级为“可验证、可协同、可发布”</a:t>
+              <a:t>把“会修复”升级为“带证据、可发布、可复用”</a:t>
             </a:r>
           </a:p>
         </p:txBody>
@@ -15759,7 +15758,7 @@
                   <a:srgbClr val="64748B"/>
                 </a:solidFill>
               </a:rPr>
-              <a:t>复赛版补齐动态协同、可发现 Skill、异常注入、评测、权限与开源规范。</a:t>
+              <a:t>复赛版补齐 AgentTeams、云 Skill、评测、失败处理、权限与开源规范。</a:t>
             </a:r>
           </a:p>
         </p:txBody>
@@ -15896,7 +15895,7 @@
                   <a:srgbClr val="101828"/>
                 </a:solidFill>
               </a:rPr>
-              <a:t>ChronosFix（A-CFX）</a:t>
+              <a:t>AsoulAI ChronosFix（A-CFX）</a:t>
             </a:r>
           </a:p>
           <a:p xmlns:a="http://schemas.openxmlformats.org/drawingml/2006/main">
@@ -15914,7 +15913,7 @@
                   <a:srgbClr val="101828"/>
                 </a:solidFill>
               </a:rPr>
-              <a:t>带证明的软件变更基础设施</a:t>
+              <a:t>带证据的软件修复引擎</a:t>
             </a:r>
           </a:p>
         </p:txBody>
@@ -16188,7 +16187,7 @@
                   <a:srgbClr val="101828"/>
                 </a:solidFill>
               </a:rPr>
-              <a:t>DynamicScheduler 驱动 8 个 Worker；证据触发任务插入、失败重派与人工恢复。</a:t>
+              <a:t>8 个职能 Worker 协同重放事故；10 个 Skill 能力完成因果、验证、门禁与资产沉淀。</a:t>
             </a:r>
           </a:p>
         </p:txBody>
@@ -16325,7 +16324,7 @@
                   <a:srgbClr val="101828"/>
                 </a:solidFill>
               </a:rPr>
-              <a:t>Proof-Carrying Change + 动态协同：无法区分就拒答，证据不全就阻断发布。</a:t>
+              <a:t>Proof-Carrying Change + 可辨识性仲裁：无法区分就拒答，证据不全就阻断发布。</a:t>
             </a:r>
           </a:p>
         </p:txBody>
@@ -16599,7 +16598,7 @@
                   <a:srgbClr val="101828"/>
                 </a:solidFill>
               </a:rPr>
-              <a:t>40 项测试；9/9 支持范围诊断正确；1/1 冲突安全拒答；动态协同有运行证据。</a:t>
+              <a:t>40 项测试；9/9 支持范围诊断正确；1/1 冲突安全拒答；2 项边界透明保留。</a:t>
             </a:r>
           </a:p>
         </p:txBody>
@@ -18581,7 +18580,7 @@
                   <a:srgbClr val="101828"/>
                 </a:solidFill>
               </a:rPr>
-              <a:t>当前状态：本地动态控制面已实测；Controller / Matrix、真实 SLS 与 canary 仍待外部环境。</a:t>
+              <a:t>当前状态：Controller / Matrix 尚未执行；真实 SLS 需要本地只读凭证；其余推荐组件为迁移目标。</a:t>
             </a:r>
           </a:p>
         </p:txBody>
@@ -19223,7 +19222,7 @@
                   <a:srgbClr val="101828"/>
                 </a:solidFill>
               </a:rPr>
-              <a:t>ChronosFix：软件故障时间机器</a:t>
+              <a:t>AsoulAI ChronosFix：带证据的软件修复引擎</a:t>
             </a:r>
           </a:p>
         </p:txBody>
@@ -19909,7 +19908,7 @@
                   <a:srgbClr val="101828"/>
                 </a:solidFill>
               </a:rPr>
-              <a:t>根因可证明｜补丁可验证｜发布可审计｜事故可复用</a:t>
+              <a:t>根因可证明｜补丁可验证｜发布可审计｜经验可复用</a:t>
             </a:r>
           </a:p>
         </p:txBody>
@@ -19960,7 +19959,7 @@
                   <a:srgbClr val="101828"/>
                 </a:solidFill>
               </a:rPr>
-              <a:t>A-CFX：让每次软件变更都携带证据，让每次事故都沉淀为质量资产。</a:t>
+              <a:t>A-CFX：让每次软件修复都携带证据，让每次事故都沉淀为质量资产。</a:t>
             </a:r>
           </a:p>
         </p:txBody>
@@ -22452,7 +22451,7 @@
                   <a:srgbClr val="2563EB"/>
                 </a:solidFill>
               </a:rPr>
-              <a:t>13</a:t>
+              <a:t>14</a:t>
             </a:r>
           </a:p>
         </p:txBody>
@@ -24907,7 +24906,7 @@
                   <a:srgbClr val="101828"/>
                 </a:solidFill>
               </a:rPr>
-              <a:t>18 个 Span、6 个动态任务、38 个协同事件；均关联同一 run_id。</a:t>
+              <a:t>18 个实测 Span、3 个必须 checks、15 个主输出文件；全部关联同一 run_id。</a:t>
             </a:r>
           </a:p>
         </p:txBody>
@@ -25711,7 +25710,7 @@
                   <a:srgbClr val="101828"/>
                 </a:solidFill>
               </a:rPr>
-              <a:t>AgentTeams v1beta1：资源声明与动态任务图</a:t>
+              <a:t>AgentTeams v1beta1：正式资源已离线校验</a:t>
             </a:r>
           </a:p>
         </p:txBody>
@@ -27680,7 +27679,7 @@
                   <a:srgbClr val="101828"/>
                 </a:solidFill>
               </a:rPr>
-              <a:t>角色靠状态契约协同，任务会随证据变化</a:t>
+              <a:t>角色靠状态契约协同，而不是在聊天室投票</a:t>
             </a:r>
           </a:p>
         </p:txBody>
@@ -27731,7 +27730,7 @@
                   <a:srgbClr val="64748B"/>
                 </a:solidFill>
               </a:rPr>
-              <a:t>Worker 只写负责分区；Commander 做路由、裁决与升级；新证据可插入任务。</a:t>
+              <a:t>每个 Worker 只写负责的状态分区；Commander 只做路由、裁决与升级。</a:t>
             </a:r>
           </a:p>
         </p:txBody>
@@ -29139,8 +29138,8 @@
                   <a:srgbClr val="101828"/>
                 </a:solidFill>
               </a:rPr>
-              <a:t>IncidentState + revision
-任务图 / 实验 / 补丁 / 审批</a:t>
+              <a:t>IncidentState + Schema
+实验 / 补丁 / 审批</a:t>
             </a:r>
           </a:p>
         </p:txBody>
@@ -29277,8 +29276,8 @@
                   <a:srgbClr val="101828"/>
                 </a:solidFill>
               </a:rPr>
-              <a:t>run / trace / state revision
-attempt / reassign / PR</a:t>
+              <a:t>run / trace / parent
+Agent / check / PR</a:t>
             </a:r>
           </a:p>
         </p:txBody>
@@ -29415,8 +29414,8 @@
                   <a:srgbClr val="101828"/>
                 </a:solidFill>
               </a:rPr>
-              <a:t>timeout→reassign / duplicate→dedup
-stale approval→pause</a:t>
+              <a:t>missing / indeterminate
+高风险→Human</a:t>
             </a:r>
           </a:p>
         </p:txBody>

</xml_diff>

<commit_message>
docs: align semifinal materials with AgentTeams rubric
</commit_message>
<xml_diff>
--- a/submission/ChronosFix_复赛方案.pptx
+++ b/submission/ChronosFix_复赛方案.pptx
@@ -2,34 +2,34 @@
 <file path=ppt/presentation.xml><?xml version="1.0" encoding="utf-8"?>
 <p:presentation xmlns:p="http://schemas.openxmlformats.org/presentationml/2006/main">
   <p:sldMasterIdLst>
-    <p:sldMasterId xmlns:r="http://schemas.openxmlformats.org/officeDocument/2006/relationships" id="2147483648" r:id="R00cf9fb651d54a97"/>
+    <p:sldMasterId xmlns:r="http://schemas.openxmlformats.org/officeDocument/2006/relationships" id="2147483648" r:id="R00916bdf6ae344b6"/>
   </p:sldMasterIdLst>
   <p:notesMasterIdLst>
-    <p:notesMasterId xmlns:r="http://schemas.openxmlformats.org/officeDocument/2006/relationships" r:id="R2d9cb5e7e38a4641"/>
+    <p:notesMasterId xmlns:r="http://schemas.openxmlformats.org/officeDocument/2006/relationships" r:id="R16102d87108e453d"/>
   </p:notesMasterIdLst>
   <p:sldIdLst>
-    <p:sldId xmlns:r="http://schemas.openxmlformats.org/officeDocument/2006/relationships" id="256" r:id="R805ce8595c5d4fb4"/>
-    <p:sldId xmlns:r="http://schemas.openxmlformats.org/officeDocument/2006/relationships" id="257" r:id="R5fa2c240d5ad4f40"/>
-    <p:sldId xmlns:r="http://schemas.openxmlformats.org/officeDocument/2006/relationships" id="258" r:id="Rd26f2698bb59464d"/>
-    <p:sldId xmlns:r="http://schemas.openxmlformats.org/officeDocument/2006/relationships" id="259" r:id="Rac30409ebf304925"/>
-    <p:sldId xmlns:r="http://schemas.openxmlformats.org/officeDocument/2006/relationships" id="260" r:id="Rc5e1d13a952c44c3"/>
-    <p:sldId xmlns:r="http://schemas.openxmlformats.org/officeDocument/2006/relationships" id="261" r:id="R6ca09dd30b6f41a4"/>
-    <p:sldId xmlns:r="http://schemas.openxmlformats.org/officeDocument/2006/relationships" id="262" r:id="Rb3651b32f2784b88"/>
-    <p:sldId xmlns:r="http://schemas.openxmlformats.org/officeDocument/2006/relationships" id="263" r:id="Rb6a328eebcaa4997"/>
-    <p:sldId xmlns:r="http://schemas.openxmlformats.org/officeDocument/2006/relationships" id="264" r:id="Rec9cbd252ac54464"/>
-    <p:sldId xmlns:r="http://schemas.openxmlformats.org/officeDocument/2006/relationships" id="265" r:id="R403eb57f87024e9a"/>
-    <p:sldId xmlns:r="http://schemas.openxmlformats.org/officeDocument/2006/relationships" id="266" r:id="R26197a75ec2a49f8"/>
-    <p:sldId xmlns:r="http://schemas.openxmlformats.org/officeDocument/2006/relationships" id="267" r:id="R89d7bb3c6f224617"/>
-    <p:sldId xmlns:r="http://schemas.openxmlformats.org/officeDocument/2006/relationships" id="268" r:id="Re77ac2779caa4051"/>
-    <p:sldId xmlns:r="http://schemas.openxmlformats.org/officeDocument/2006/relationships" id="269" r:id="R1793abecee3645e1"/>
-    <p:sldId xmlns:r="http://schemas.openxmlformats.org/officeDocument/2006/relationships" id="270" r:id="Rcba346e719244083"/>
-    <p:sldId xmlns:r="http://schemas.openxmlformats.org/officeDocument/2006/relationships" id="271" r:id="R64917e7d87f44e7b"/>
-    <p:sldId xmlns:r="http://schemas.openxmlformats.org/officeDocument/2006/relationships" id="272" r:id="Rc8e9f3dd2e504c57"/>
-    <p:sldId xmlns:r="http://schemas.openxmlformats.org/officeDocument/2006/relationships" id="273" r:id="R120383195af2451b"/>
-    <p:sldId xmlns:r="http://schemas.openxmlformats.org/officeDocument/2006/relationships" id="274" r:id="Ra63b70d6a1be4c94"/>
-    <p:sldId xmlns:r="http://schemas.openxmlformats.org/officeDocument/2006/relationships" id="275" r:id="R5578936462074e84"/>
-    <p:sldId xmlns:r="http://schemas.openxmlformats.org/officeDocument/2006/relationships" id="276" r:id="R84f636f6189b42dc"/>
-    <p:sldId xmlns:r="http://schemas.openxmlformats.org/officeDocument/2006/relationships" id="277" r:id="R0587277463544e99"/>
+    <p:sldId xmlns:r="http://schemas.openxmlformats.org/officeDocument/2006/relationships" id="256" r:id="Rcf9e44d3dbae41d9"/>
+    <p:sldId xmlns:r="http://schemas.openxmlformats.org/officeDocument/2006/relationships" id="257" r:id="Rc95e227b4b324940"/>
+    <p:sldId xmlns:r="http://schemas.openxmlformats.org/officeDocument/2006/relationships" id="258" r:id="Ra93a22de4adb4091"/>
+    <p:sldId xmlns:r="http://schemas.openxmlformats.org/officeDocument/2006/relationships" id="259" r:id="Raf00f36d5cda4678"/>
+    <p:sldId xmlns:r="http://schemas.openxmlformats.org/officeDocument/2006/relationships" id="260" r:id="R53f81c304c4a4f9b"/>
+    <p:sldId xmlns:r="http://schemas.openxmlformats.org/officeDocument/2006/relationships" id="261" r:id="R65b7a0e7754f4fdf"/>
+    <p:sldId xmlns:r="http://schemas.openxmlformats.org/officeDocument/2006/relationships" id="262" r:id="R203f0bd5f5424a16"/>
+    <p:sldId xmlns:r="http://schemas.openxmlformats.org/officeDocument/2006/relationships" id="263" r:id="Re33487bddea1404e"/>
+    <p:sldId xmlns:r="http://schemas.openxmlformats.org/officeDocument/2006/relationships" id="264" r:id="R7dd4107311ea46e9"/>
+    <p:sldId xmlns:r="http://schemas.openxmlformats.org/officeDocument/2006/relationships" id="265" r:id="R090cd0deb1f7436f"/>
+    <p:sldId xmlns:r="http://schemas.openxmlformats.org/officeDocument/2006/relationships" id="266" r:id="Re3a7186982064f35"/>
+    <p:sldId xmlns:r="http://schemas.openxmlformats.org/officeDocument/2006/relationships" id="267" r:id="Re84d466830e64b03"/>
+    <p:sldId xmlns:r="http://schemas.openxmlformats.org/officeDocument/2006/relationships" id="268" r:id="R5905930c41384806"/>
+    <p:sldId xmlns:r="http://schemas.openxmlformats.org/officeDocument/2006/relationships" id="269" r:id="Re51dd2714a794140"/>
+    <p:sldId xmlns:r="http://schemas.openxmlformats.org/officeDocument/2006/relationships" id="270" r:id="R6697b7bfc0594303"/>
+    <p:sldId xmlns:r="http://schemas.openxmlformats.org/officeDocument/2006/relationships" id="271" r:id="Rd76cae26f77241f3"/>
+    <p:sldId xmlns:r="http://schemas.openxmlformats.org/officeDocument/2006/relationships" id="272" r:id="Rd3f9f5edd3974e5c"/>
+    <p:sldId xmlns:r="http://schemas.openxmlformats.org/officeDocument/2006/relationships" id="273" r:id="R696a39a26b3345af"/>
+    <p:sldId xmlns:r="http://schemas.openxmlformats.org/officeDocument/2006/relationships" id="274" r:id="R5927ef6b78e94606"/>
+    <p:sldId xmlns:r="http://schemas.openxmlformats.org/officeDocument/2006/relationships" id="275" r:id="R5ee03c75bcd54aec"/>
+    <p:sldId xmlns:r="http://schemas.openxmlformats.org/officeDocument/2006/relationships" id="276" r:id="Rc382a1279cc64a84"/>
+    <p:sldId xmlns:r="http://schemas.openxmlformats.org/officeDocument/2006/relationships" id="277" r:id="Rfffc4733fc35459d"/>
   </p:sldIdLst>
   <p:sldSz cx="12192000" cy="6858000"/>
   <p:notesSz cx="6858000" cy="9144000"/>
@@ -2381,7 +2381,7 @@
   </p:cSld>
   <p:clrMap bg1="lt1" tx1="dk1" bg2="lt2" tx2="dk2" accent1="accent1" accent2="accent2" accent3="accent3" accent4="accent4" accent5="accent5" accent6="accent6" hlink="hlink" folHlink="folHlink"/>
   <p:sldLayoutIdLst>
-    <p:sldLayoutId xmlns:r="http://schemas.openxmlformats.org/officeDocument/2006/relationships" id="2147483649" r:id="R3852b636973141ab"/>
+    <p:sldLayoutId xmlns:r="http://schemas.openxmlformats.org/officeDocument/2006/relationships" id="2147483649" r:id="Rfea96b96c11d4339"/>
   </p:sldLayoutIdLst>
   <p:txStyles>
     <p:titleStyle>
@@ -15759,7 +15759,7 @@
                   <a:srgbClr val="64748B"/>
                 </a:solidFill>
               </a:rPr>
-              <a:t>复赛版补齐动态协同、可发现 Skill、异常注入、评测、权限与开源规范。</a:t>
+              <a:t>初赛：固定演示链路；复赛新增：Manager 按证据自由组合 Agent/Skill、动态协同、异常注入与 57 项验收。</a:t>
             </a:r>
           </a:p>
         </p:txBody>
@@ -16548,7 +16548,7 @@
                   <a:srgbClr val="DC2626"/>
                 </a:solidFill>
               </a:rPr>
-              <a:t>当前进展</a:t>
+              <a:t>复赛新增 · 红字对比</a:t>
             </a:r>
           </a:p>
         </p:txBody>

</xml_diff>

<commit_message>
release: align official work title across semifinal artifacts
</commit_message>
<xml_diff>
--- a/submission/ChronosFix_复赛方案.pptx
+++ b/submission/ChronosFix_复赛方案.pptx
@@ -2,34 +2,34 @@
 <file path=ppt/presentation.xml><?xml version="1.0" encoding="utf-8"?>
 <p:presentation xmlns:p="http://schemas.openxmlformats.org/presentationml/2006/main">
   <p:sldMasterIdLst>
-    <p:sldMasterId xmlns:r="http://schemas.openxmlformats.org/officeDocument/2006/relationships" id="2147483648" r:id="Rddc9c6a64462443d"/>
+    <p:sldMasterId xmlns:r="http://schemas.openxmlformats.org/officeDocument/2006/relationships" id="2147483648" r:id="R38f0fc3f40114634"/>
   </p:sldMasterIdLst>
   <p:notesMasterIdLst>
-    <p:notesMasterId xmlns:r="http://schemas.openxmlformats.org/officeDocument/2006/relationships" r:id="Rc7a2f77f62dd459f"/>
+    <p:notesMasterId xmlns:r="http://schemas.openxmlformats.org/officeDocument/2006/relationships" r:id="Re07af39a8f9e4e08"/>
   </p:notesMasterIdLst>
   <p:sldIdLst>
-    <p:sldId xmlns:r="http://schemas.openxmlformats.org/officeDocument/2006/relationships" id="256" r:id="Rdc89bf51676448a4"/>
-    <p:sldId xmlns:r="http://schemas.openxmlformats.org/officeDocument/2006/relationships" id="257" r:id="Rac49a12d68144f4f"/>
-    <p:sldId xmlns:r="http://schemas.openxmlformats.org/officeDocument/2006/relationships" id="258" r:id="R4d523673c9794afe"/>
-    <p:sldId xmlns:r="http://schemas.openxmlformats.org/officeDocument/2006/relationships" id="259" r:id="R5d3d6665b36b448b"/>
-    <p:sldId xmlns:r="http://schemas.openxmlformats.org/officeDocument/2006/relationships" id="260" r:id="Ra080757abc814d16"/>
-    <p:sldId xmlns:r="http://schemas.openxmlformats.org/officeDocument/2006/relationships" id="261" r:id="Rd392f349817c4a4f"/>
-    <p:sldId xmlns:r="http://schemas.openxmlformats.org/officeDocument/2006/relationships" id="262" r:id="R94e32abeffac4edc"/>
-    <p:sldId xmlns:r="http://schemas.openxmlformats.org/officeDocument/2006/relationships" id="263" r:id="Rcb70eaacac2a49b1"/>
-    <p:sldId xmlns:r="http://schemas.openxmlformats.org/officeDocument/2006/relationships" id="264" r:id="R81a7622069a74b5a"/>
-    <p:sldId xmlns:r="http://schemas.openxmlformats.org/officeDocument/2006/relationships" id="265" r:id="Rff54f1c322554b67"/>
-    <p:sldId xmlns:r="http://schemas.openxmlformats.org/officeDocument/2006/relationships" id="266" r:id="Rc556f02849f34b14"/>
-    <p:sldId xmlns:r="http://schemas.openxmlformats.org/officeDocument/2006/relationships" id="267" r:id="Re3b49412af464497"/>
-    <p:sldId xmlns:r="http://schemas.openxmlformats.org/officeDocument/2006/relationships" id="268" r:id="Recab2f4e3a904260"/>
-    <p:sldId xmlns:r="http://schemas.openxmlformats.org/officeDocument/2006/relationships" id="269" r:id="R195fc0b8eddf462b"/>
-    <p:sldId xmlns:r="http://schemas.openxmlformats.org/officeDocument/2006/relationships" id="270" r:id="R6b82953a64dd4707"/>
-    <p:sldId xmlns:r="http://schemas.openxmlformats.org/officeDocument/2006/relationships" id="271" r:id="Rd54b2868bb8444d2"/>
-    <p:sldId xmlns:r="http://schemas.openxmlformats.org/officeDocument/2006/relationships" id="272" r:id="R9d44a5b4df504f64"/>
-    <p:sldId xmlns:r="http://schemas.openxmlformats.org/officeDocument/2006/relationships" id="273" r:id="Rfc2e5f9936a546b3"/>
-    <p:sldId xmlns:r="http://schemas.openxmlformats.org/officeDocument/2006/relationships" id="274" r:id="Rcdeb3db3ea2b4295"/>
-    <p:sldId xmlns:r="http://schemas.openxmlformats.org/officeDocument/2006/relationships" id="275" r:id="R777d98c707a44e4c"/>
-    <p:sldId xmlns:r="http://schemas.openxmlformats.org/officeDocument/2006/relationships" id="276" r:id="Rf8d90f1fc15f4f30"/>
-    <p:sldId xmlns:r="http://schemas.openxmlformats.org/officeDocument/2006/relationships" id="277" r:id="R7d00fc05613048a5"/>
+    <p:sldId xmlns:r="http://schemas.openxmlformats.org/officeDocument/2006/relationships" id="256" r:id="Reaac42e0590d45fe"/>
+    <p:sldId xmlns:r="http://schemas.openxmlformats.org/officeDocument/2006/relationships" id="257" r:id="Rf95d9629e69e469b"/>
+    <p:sldId xmlns:r="http://schemas.openxmlformats.org/officeDocument/2006/relationships" id="258" r:id="R7ef7d69b68d74b6f"/>
+    <p:sldId xmlns:r="http://schemas.openxmlformats.org/officeDocument/2006/relationships" id="259" r:id="R525325b445e24dd3"/>
+    <p:sldId xmlns:r="http://schemas.openxmlformats.org/officeDocument/2006/relationships" id="260" r:id="R9720f5235de84609"/>
+    <p:sldId xmlns:r="http://schemas.openxmlformats.org/officeDocument/2006/relationships" id="261" r:id="Rb16b82cb18fa4f23"/>
+    <p:sldId xmlns:r="http://schemas.openxmlformats.org/officeDocument/2006/relationships" id="262" r:id="R907cb1a58a6341f1"/>
+    <p:sldId xmlns:r="http://schemas.openxmlformats.org/officeDocument/2006/relationships" id="263" r:id="Rc5ece80204704d56"/>
+    <p:sldId xmlns:r="http://schemas.openxmlformats.org/officeDocument/2006/relationships" id="264" r:id="Rd32b417b89584b68"/>
+    <p:sldId xmlns:r="http://schemas.openxmlformats.org/officeDocument/2006/relationships" id="265" r:id="R512c99b9b29d4e84"/>
+    <p:sldId xmlns:r="http://schemas.openxmlformats.org/officeDocument/2006/relationships" id="266" r:id="R0f43fcb320724c81"/>
+    <p:sldId xmlns:r="http://schemas.openxmlformats.org/officeDocument/2006/relationships" id="267" r:id="R83a9a7056a104fb6"/>
+    <p:sldId xmlns:r="http://schemas.openxmlformats.org/officeDocument/2006/relationships" id="268" r:id="R371c3770aa6e41c6"/>
+    <p:sldId xmlns:r="http://schemas.openxmlformats.org/officeDocument/2006/relationships" id="269" r:id="R183ef11ad0be46e5"/>
+    <p:sldId xmlns:r="http://schemas.openxmlformats.org/officeDocument/2006/relationships" id="270" r:id="R7e0b0bf6a7bb42ab"/>
+    <p:sldId xmlns:r="http://schemas.openxmlformats.org/officeDocument/2006/relationships" id="271" r:id="Ra0984070e2f241bd"/>
+    <p:sldId xmlns:r="http://schemas.openxmlformats.org/officeDocument/2006/relationships" id="272" r:id="R243c10eaad104720"/>
+    <p:sldId xmlns:r="http://schemas.openxmlformats.org/officeDocument/2006/relationships" id="273" r:id="R4bdbdc40b9e746ec"/>
+    <p:sldId xmlns:r="http://schemas.openxmlformats.org/officeDocument/2006/relationships" id="274" r:id="Rfd4b89e8515b42a9"/>
+    <p:sldId xmlns:r="http://schemas.openxmlformats.org/officeDocument/2006/relationships" id="275" r:id="Raa9b7c31832645a9"/>
+    <p:sldId xmlns:r="http://schemas.openxmlformats.org/officeDocument/2006/relationships" id="276" r:id="Re6080525c2b2400e"/>
+    <p:sldId xmlns:r="http://schemas.openxmlformats.org/officeDocument/2006/relationships" id="277" r:id="Rf21be10f9b7547a2"/>
   </p:sldIdLst>
   <p:sldSz cx="12192000" cy="6858000"/>
   <p:notesSz cx="6858000" cy="9144000"/>
@@ -2381,7 +2381,7 @@
   </p:cSld>
   <p:clrMap bg1="lt1" tx1="dk1" bg2="lt2" tx2="dk2" accent1="accent1" accent2="accent2" accent3="accent3" accent4="accent4" accent5="accent5" accent6="accent6" hlink="hlink" folHlink="folHlink"/>
   <p:sldLayoutIdLst>
-    <p:sldLayoutId xmlns:r="http://schemas.openxmlformats.org/officeDocument/2006/relationships" id="2147483649" r:id="R1850ca99276b497b"/>
+    <p:sldLayoutId xmlns:r="http://schemas.openxmlformats.org/officeDocument/2006/relationships" id="2147483649" r:id="R4742691c7c1e4d83"/>
   </p:sldLayoutIdLst>
   <p:txStyles>
     <p:titleStyle>
@@ -15896,7 +15896,15 @@
                   <a:srgbClr val="101828"/>
                 </a:solidFill>
               </a:rPr>
-              <a:t>ChronosFix（A-CFX）</a:t>
+              <a:t>AsoulAI ChronosFix</a:t>
+            </a:r>
+            <a:r>
+              <a:rPr sz="1200" b="0">
+                <a:solidFill>
+                  <a:srgbClr val="101828"/>
+                </a:solidFill>
+              </a:rPr>
+              <a:t>（A-CFX）</a:t>
             </a:r>
           </a:p>
           <a:p xmlns:a="http://schemas.openxmlformats.org/drawingml/2006/main">
@@ -15914,7 +15922,7 @@
                   <a:srgbClr val="101828"/>
                 </a:solidFill>
               </a:rPr>
-              <a:t>带证明的软件变更基础设施</a:t>
+              <a:t>软件故障时间机器</a:t>
             </a:r>
           </a:p>
         </p:txBody>

</xml_diff>